<commit_message>
Update works done through Month 5-6: add demo network, Strict SingleKey demo, multikey scheme doc, Month 5-6 presentation & simulation, FL/CKKS explainer, conference paper draft, comparison scripts, and presentation speech sheet. Remove Claude attribution from contributions.
</commit_message>
<xml_diff>
--- a/5th Month Progress/Newly Added - Month 5/Month5_Status_Update.pptx
+++ b/5th Month Progress/Newly Added - Month 5/Month5_Status_Update.pptx
@@ -4,6 +4,9 @@
   <p:sldMasterIdLst>
     <p:sldMasterId id="2147483648" r:id="rId1"/>
   </p:sldMasterIdLst>
+  <p:notesMasterIdLst>
+    <p:notesMasterId r:id="rId15"/>
+  </p:notesMasterIdLst>
   <p:sldIdLst>
     <p:sldId id="256" r:id="rId2"/>
     <p:sldId id="257" r:id="rId3"/>
@@ -19,9 +22,6 @@
     <p:sldId id="267" r:id="rId13"/>
     <p:sldId id="268" r:id="rId14"/>
   </p:sldIdLst>
-  <p:notesMasterIdLst>
-    <p:notesMasterId r:id="rId15"/>
-  </p:notesMasterIdLst>
   <p:sldSz cx="12192000" cy="6858000"/>
   <p:notesSz cx="6858000" cy="12192000"/>
   <p:defaultTextStyle>
@@ -116,13 +116,20 @@
       </a:defRPr>
     </a:lvl9pPr>
   </p:defaultTextStyle>
+  <p:extLst>
+    <p:ext uri="{EFAFB233-063F-42B5-8137-9DF3F51BA10A}">
+      <p15:sldGuideLst xmlns:p15="http://schemas.microsoft.com/office/powerpoint/2012/main"/>
+    </p:ext>
+  </p:extLst>
 </p:presentation>
 </file>
 
 <file path=ppt/charts/chart1.xml><?xml version="1.0" encoding="utf-8"?>
-<c:chartSpace xmlns:c="http://schemas.openxmlformats.org/drawingml/2006/chart" xmlns:a="http://schemas.openxmlformats.org/drawingml/2006/main" xmlns:r="http://schemas.openxmlformats.org/officeDocument/2006/relationships">
+<c:chartSpace xmlns:c="http://schemas.openxmlformats.org/drawingml/2006/chart" xmlns:a="http://schemas.openxmlformats.org/drawingml/2006/main" xmlns:r="http://schemas.openxmlformats.org/officeDocument/2006/relationships" xmlns:c16r2="http://schemas.microsoft.com/office/drawing/2015/06/chart">
   <c:date1904 val="0"/>
+  <c:lang val="en-US"/>
   <c:roundedCorners val="1"/>
+  <c:style val="2"/>
   <c:chart>
     <c:autoTitleDeleted val="1"/>
     <c:plotArea>
@@ -154,18 +161,26 @@
           <c:invertIfNegative val="0"/>
           <c:dLbls>
             <c:numFmt formatCode="0.000" sourceLinked="0"/>
+            <c:spPr>
+              <a:noFill/>
+              <a:ln>
+                <a:noFill/>
+              </a:ln>
+              <a:effectLst/>
+            </c:spPr>
             <c:txPr>
               <a:bodyPr/>
               <a:lstStyle/>
               <a:p>
                 <a:pPr>
-                  <a:defRPr b="0" i="0" strike="noStrike" sz="950" u="none">
+                  <a:defRPr sz="950" b="0" i="0" u="none" strike="noStrike">
                     <a:solidFill>
                       <a:srgbClr val="1A1A2E"/>
                     </a:solidFill>
                     <a:latin typeface="Arial"/>
                   </a:defRPr>
                 </a:pPr>
+                <a:endParaRPr lang="en-US"/>
               </a:p>
             </c:txPr>
             <c:showLegendKey val="0"/>
@@ -175,28 +190,31 @@
             <c:showPercent val="0"/>
             <c:showBubbleSize val="0"/>
             <c:showLeaderLines val="0"/>
+            <c:extLst>
+              <c:ext xmlns:c15="http://schemas.microsoft.com/office/drawing/2012/chart" uri="{CE6537A1-D6FC-4f65-9D91-7224C49458BB}">
+                <c15:showLeaderLines val="0"/>
+              </c:ext>
+            </c:extLst>
           </c:dLbls>
           <c:cat>
-            <c:multiLvlStrRef>
+            <c:strRef>
               <c:f>Sheet1!$A$2:$A$5</c:f>
-              <c:multiLvlStrCache>
+              <c:strCache>
                 <c:ptCount val="4"/>
-                <c:lvl>
-                  <c:pt idx="0">
-                    <c:v>CAN-VTC</c:v>
-                  </c:pt>
-                  <c:pt idx="1">
-                    <c:v>Car-Hacking</c:v>
-                  </c:pt>
-                  <c:pt idx="2">
-                    <c:v>CICIDS-2017</c:v>
-                  </c:pt>
-                  <c:pt idx="3">
-                    <c:v>VeReMi</c:v>
-                  </c:pt>
-                </c:lvl>
-              </c:multiLvlStrCache>
-            </c:multiLvlStrRef>
+                <c:pt idx="0">
+                  <c:v>CAN-VTC</c:v>
+                </c:pt>
+                <c:pt idx="1">
+                  <c:v>Car-Hacking</c:v>
+                </c:pt>
+                <c:pt idx="2">
+                  <c:v>CICIDS-2017</c:v>
+                </c:pt>
+                <c:pt idx="3">
+                  <c:v>VeReMi</c:v>
+                </c:pt>
+              </c:strCache>
+            </c:strRef>
           </c:cat>
           <c:val>
             <c:numRef>
@@ -208,10 +226,10 @@
                   <c:v>1</c:v>
                 </c:pt>
                 <c:pt idx="1">
-                  <c:v>0.9977</c:v>
+                  <c:v>0.99770000000000003</c:v>
                 </c:pt>
                 <c:pt idx="2">
-                  <c:v>0.9555</c:v>
+                  <c:v>0.95550000000000002</c:v>
                 </c:pt>
                 <c:pt idx="3">
                   <c:v>0.4839</c:v>
@@ -219,6 +237,11 @@
               </c:numCache>
             </c:numRef>
           </c:val>
+          <c:extLst>
+            <c:ext xmlns:c16="http://schemas.microsoft.com/office/drawing/2014/chart" uri="{C3380CC4-5D6E-409C-BE32-E72D297353CC}">
+              <c16:uniqueId val="{00000000-9582-468D-B05B-5E11CF048C25}"/>
+            </c:ext>
+          </c:extLst>
         </c:ser>
         <c:ser>
           <c:idx val="1"/>
@@ -243,18 +266,26 @@
           <c:invertIfNegative val="0"/>
           <c:dLbls>
             <c:numFmt formatCode="0.000" sourceLinked="0"/>
+            <c:spPr>
+              <a:noFill/>
+              <a:ln>
+                <a:noFill/>
+              </a:ln>
+              <a:effectLst/>
+            </c:spPr>
             <c:txPr>
               <a:bodyPr/>
               <a:lstStyle/>
               <a:p>
                 <a:pPr>
-                  <a:defRPr b="0" i="0" strike="noStrike" sz="950" u="none">
+                  <a:defRPr sz="950" b="0" i="0" u="none" strike="noStrike">
                     <a:solidFill>
                       <a:srgbClr val="1A1A2E"/>
                     </a:solidFill>
                     <a:latin typeface="Arial"/>
                   </a:defRPr>
                 </a:pPr>
+                <a:endParaRPr lang="en-US"/>
               </a:p>
             </c:txPr>
             <c:showLegendKey val="0"/>
@@ -264,28 +295,31 @@
             <c:showPercent val="0"/>
             <c:showBubbleSize val="0"/>
             <c:showLeaderLines val="0"/>
+            <c:extLst>
+              <c:ext xmlns:c15="http://schemas.microsoft.com/office/drawing/2012/chart" uri="{CE6537A1-D6FC-4f65-9D91-7224C49458BB}">
+                <c15:showLeaderLines val="0"/>
+              </c:ext>
+            </c:extLst>
           </c:dLbls>
           <c:cat>
-            <c:multiLvlStrRef>
+            <c:strRef>
               <c:f>Sheet1!$A$2:$A$5</c:f>
-              <c:multiLvlStrCache>
+              <c:strCache>
                 <c:ptCount val="4"/>
-                <c:lvl>
-                  <c:pt idx="0">
-                    <c:v>CAN-VTC</c:v>
-                  </c:pt>
-                  <c:pt idx="1">
-                    <c:v>Car-Hacking</c:v>
-                  </c:pt>
-                  <c:pt idx="2">
-                    <c:v>CICIDS-2017</c:v>
-                  </c:pt>
-                  <c:pt idx="3">
-                    <c:v>VeReMi</c:v>
-                  </c:pt>
-                </c:lvl>
-              </c:multiLvlStrCache>
-            </c:multiLvlStrRef>
+                <c:pt idx="0">
+                  <c:v>CAN-VTC</c:v>
+                </c:pt>
+                <c:pt idx="1">
+                  <c:v>Car-Hacking</c:v>
+                </c:pt>
+                <c:pt idx="2">
+                  <c:v>CICIDS-2017</c:v>
+                </c:pt>
+                <c:pt idx="3">
+                  <c:v>VeReMi</c:v>
+                </c:pt>
+              </c:strCache>
+            </c:strRef>
           </c:cat>
           <c:val>
             <c:numRef>
@@ -297,47 +331,34 @@
                   <c:v>1</c:v>
                 </c:pt>
                 <c:pt idx="1">
-                  <c:v>0.9981</c:v>
+                  <c:v>0.99809999999999999</c:v>
                 </c:pt>
                 <c:pt idx="2">
-                  <c:v>0.9542</c:v>
+                  <c:v>0.95420000000000005</c:v>
                 </c:pt>
                 <c:pt idx="3">
-                  <c:v>0.4851</c:v>
+                  <c:v>0.48509999999999998</c:v>
                 </c:pt>
               </c:numCache>
             </c:numRef>
           </c:val>
+          <c:extLst>
+            <c:ext xmlns:c16="http://schemas.microsoft.com/office/drawing/2014/chart" uri="{C3380CC4-5D6E-409C-BE32-E72D297353CC}">
+              <c16:uniqueId val="{00000001-9582-468D-B05B-5E11CF048C25}"/>
+            </c:ext>
+          </c:extLst>
         </c:ser>
         <c:dLbls>
-          <c:numFmt formatCode="0.000" sourceLinked="0"/>
-          <c:txPr>
-            <a:bodyPr/>
-            <a:lstStyle/>
-            <a:p>
-              <a:pPr>
-                <a:defRPr b="0" i="0" strike="noStrike" sz="950" u="none">
-                  <a:solidFill>
-                    <a:srgbClr val="1A1A2E"/>
-                  </a:solidFill>
-                  <a:latin typeface="Arial"/>
-                </a:defRPr>
-              </a:pPr>
-            </a:p>
-          </c:txPr>
           <c:showLegendKey val="0"/>
           <c:showVal val="1"/>
           <c:showCatName val="0"/>
           <c:showSerName val="0"/>
           <c:showPercent val="0"/>
           <c:showBubbleSize val="0"/>
-          <c:showLeaderLines val="0"/>
         </c:dLbls>
         <c:gapWidth val="55"/>
-        <c:overlap val="0"/>
         <c:axId val="2094734554"/>
         <c:axId val="2094734552"/>
-        <c:axId val="2094734556"/>
       </c:barChart>
       <c:catAx>
         <c:axId val="2094734554"/>
@@ -378,13 +399,14 @@
         <c:crosses val="autoZero"/>
         <c:auto val="1"/>
         <c:lblAlgn val="ctr"/>
+        <c:lblOffset val="100"/>
         <c:noMultiLvlLbl val="1"/>
       </c:catAx>
       <c:valAx>
         <c:axId val="2094734552"/>
         <c:scaling>
           <c:orientation val="minMax"/>
-          <c:max val="1.15"/>
+          <c:max val="1.1499999999999999"/>
           <c:min val="0"/>
         </c:scaling>
         <c:delete val="0"/>
@@ -448,7 +470,7 @@
         <a:lstStyle/>
         <a:p>
           <a:pPr>
-            <a:defRPr sz="1100">      </a:defRPr>
+            <a:defRPr sz="1100"/>
           </a:pPr>
           <a:endParaRPr lang="en-US"/>
         </a:p>
@@ -456,6 +478,7 @@
     </c:legend>
     <c:plotVisOnly val="1"/>
     <c:dispBlanksAs val="span"/>
+    <c:showDLblsOverMax val="1"/>
   </c:chart>
   <c:spPr>
     <a:noFill/>
@@ -492,234 +515,10 @@
           <a:chExt cx="0" cy="0"/>
         </a:xfrm>
       </p:grpSpPr>
-      <p:sp>
-        <p:nvSpPr>
-          <p:cNvPr id="2" name="Header Placeholder 1"/>
-          <p:cNvSpPr>
-            <a:spLocks noGrp="1"/>
-          </p:cNvSpPr>
-          <p:nvPr>
-            <p:ph type="hdr" sz="quarter"/>
-          </p:nvPr>
-        </p:nvSpPr>
-        <p:spPr>
-          <a:xfrm>
-            <a:off x="0" y="0"/>
-            <a:ext cx="2971800" cy="458788"/>
-          </a:xfrm>
-          <a:prstGeom prst="rect">
-            <a:avLst/>
-          </a:prstGeom>
-        </p:spPr>
-        <p:txBody>
-          <a:bodyPr vert="horz" lIns="91440" tIns="45720" rIns="91440" bIns="45720" rtlCol="0"/>
-          <a:lstStyle>
-            <a:lvl1pPr algn="l">
-              <a:defRPr sz="1200"/>
-            </a:lvl1pPr>
-          </a:lstStyle>
-          <a:p>
-            <a:endParaRPr lang="en-US"/>
-          </a:p>
-        </p:txBody>
-      </p:sp>
-      <p:sp>
-        <p:nvSpPr>
-          <p:cNvPr id="3" name="Date Placeholder 2"/>
-          <p:cNvSpPr>
-            <a:spLocks noGrp="1"/>
-          </p:cNvSpPr>
-          <p:nvPr>
-            <p:ph type="dt" idx="1"/>
-          </p:nvPr>
-        </p:nvSpPr>
-        <p:spPr>
-          <a:xfrm>
-            <a:off x="3884613" y="0"/>
-            <a:ext cx="2971800" cy="458788"/>
-          </a:xfrm>
-          <a:prstGeom prst="rect">
-            <a:avLst/>
-          </a:prstGeom>
-        </p:spPr>
-        <p:txBody>
-          <a:bodyPr vert="horz" lIns="91440" tIns="45720" rIns="91440" bIns="45720" rtlCol="0"/>
-          <a:lstStyle>
-            <a:lvl1pPr algn="r">
-              <a:defRPr sz="1200"/>
-            </a:lvl1pPr>
-          </a:lstStyle>
-          <a:p>
-            <a:fld id="{5282F153-3F37-0F45-9E97-73ACFA13230C}" type="datetimeFigureOut">
-              <a:rPr lang="en-US"/>
-              <a:t>7/23/19</a:t>
-            </a:fld>
-            <a:endParaRPr lang="en-US"/>
-          </a:p>
-        </p:txBody>
-      </p:sp>
-      <p:sp>
-        <p:nvSpPr>
-          <p:cNvPr id="4" name="Slide Image Placeholder 3"/>
-          <p:cNvSpPr>
-            <a:spLocks noGrp="1" noRot="1" noChangeAspect="1"/>
-          </p:cNvSpPr>
-          <p:nvPr>
-            <p:ph type="sldImg" idx="2"/>
-          </p:nvPr>
-        </p:nvSpPr>
-        <p:spPr>
-          <a:xfrm>
-            <a:off x="685800" y="1143000"/>
-            <a:ext cx="5486400" cy="3086100"/>
-          </a:xfrm>
-          <a:prstGeom prst="rect">
-            <a:avLst/>
-          </a:prstGeom>
-          <a:noFill/>
-          <a:ln w="12700">
-            <a:solidFill>
-              <a:prstClr val="black"/>
-            </a:solidFill>
-          </a:ln>
-        </p:spPr>
-        <p:txBody>
-          <a:bodyPr vert="horz" lIns="91440" tIns="45720" rIns="91440" bIns="45720" rtlCol="0" anchor="ctr"/>
-          <a:lstStyle/>
-          <a:p>
-            <a:endParaRPr lang="en-US"/>
-          </a:p>
-        </p:txBody>
-      </p:sp>
-      <p:sp>
-        <p:nvSpPr>
-          <p:cNvPr id="5" name="Notes Placeholder 4"/>
-          <p:cNvSpPr>
-            <a:spLocks noGrp="1"/>
-          </p:cNvSpPr>
-          <p:nvPr>
-            <p:ph type="body" sz="quarter" idx="3"/>
-          </p:nvPr>
-        </p:nvSpPr>
-        <p:spPr>
-          <a:xfrm>
-            <a:off x="685800" y="4400550"/>
-            <a:ext cx="5486400" cy="3600450"/>
-          </a:xfrm>
-          <a:prstGeom prst="rect">
-            <a:avLst/>
-          </a:prstGeom>
-        </p:spPr>
-        <p:txBody>
-          <a:bodyPr vert="horz" lIns="91440" tIns="45720" rIns="91440" bIns="45720" rtlCol="0"/>
-          <a:lstStyle/>
-          <a:p>
-            <a:pPr lvl="0"/>
-            <a:r>
-              <a:rPr lang="en-US"/>
-              <a:t>Click to edit Master text styles</a:t>
-            </a:r>
-          </a:p>
-          <a:p>
-            <a:pPr lvl="1"/>
-            <a:r>
-              <a:rPr lang="en-US"/>
-              <a:t>Second level</a:t>
-            </a:r>
-          </a:p>
-          <a:p>
-            <a:pPr lvl="2"/>
-            <a:r>
-              <a:rPr lang="en-US"/>
-              <a:t>Third level</a:t>
-            </a:r>
-          </a:p>
-          <a:p>
-            <a:pPr lvl="3"/>
-            <a:r>
-              <a:rPr lang="en-US"/>
-              <a:t>Fourth level</a:t>
-            </a:r>
-          </a:p>
-          <a:p>
-            <a:pPr lvl="4"/>
-            <a:r>
-              <a:rPr lang="en-US"/>
-              <a:t>Fifth level</a:t>
-            </a:r>
-          </a:p>
-        </p:txBody>
-      </p:sp>
-      <p:sp>
-        <p:nvSpPr>
-          <p:cNvPr id="6" name="Footer Placeholder 5"/>
-          <p:cNvSpPr>
-            <a:spLocks noGrp="1"/>
-          </p:cNvSpPr>
-          <p:nvPr>
-            <p:ph type="ftr" sz="quarter" idx="4"/>
-          </p:nvPr>
-        </p:nvSpPr>
-        <p:spPr>
-          <a:xfrm>
-            <a:off x="0" y="8685213"/>
-            <a:ext cx="2971800" cy="458787"/>
-          </a:xfrm>
-          <a:prstGeom prst="rect">
-            <a:avLst/>
-          </a:prstGeom>
-        </p:spPr>
-        <p:txBody>
-          <a:bodyPr vert="horz" lIns="91440" tIns="45720" rIns="91440" bIns="45720" rtlCol="0" anchor="b"/>
-          <a:lstStyle>
-            <a:lvl1pPr algn="l">
-              <a:defRPr sz="1200"/>
-            </a:lvl1pPr>
-          </a:lstStyle>
-          <a:p>
-            <a:endParaRPr lang="en-US"/>
-          </a:p>
-        </p:txBody>
-      </p:sp>
-      <p:sp>
-        <p:nvSpPr>
-          <p:cNvPr id="7" name="Slide Number Placeholder 6"/>
-          <p:cNvSpPr>
-            <a:spLocks noGrp="1"/>
-          </p:cNvSpPr>
-          <p:nvPr>
-            <p:ph type="sldNum" sz="quarter" idx="5"/>
-          </p:nvPr>
-        </p:nvSpPr>
-        <p:spPr>
-          <a:xfrm>
-            <a:off x="3884613" y="8685213"/>
-            <a:ext cx="2971800" cy="458787"/>
-          </a:xfrm>
-          <a:prstGeom prst="rect">
-            <a:avLst/>
-          </a:prstGeom>
-        </p:spPr>
-        <p:txBody>
-          <a:bodyPr vert="horz" lIns="91440" tIns="45720" rIns="91440" bIns="45720" rtlCol="0" anchor="b"/>
-          <a:lstStyle>
-            <a:lvl1pPr algn="r">
-              <a:defRPr sz="1200"/>
-            </a:lvl1pPr>
-          </a:lstStyle>
-          <a:p>
-            <a:fld id="{CE5E9CC1-C706-0F49-92D6-E571CC5EEA8F}" type="slidenum">
-              <a:rPr lang="en-US"/>
-              <a:t>‹#›</a:t>
-            </a:fld>
-            <a:endParaRPr lang="en-US"/>
-          </a:p>
-        </p:txBody>
-      </p:sp>
     </p:spTree>
     <p:extLst>
       <p:ext uri="{BB962C8B-B14F-4D97-AF65-F5344CB8AC3E}">
-        <p14:creationId xmlns:p14="http://schemas.microsoft.com/office/powerpoint/2010/main" val="1024086991"/>
+        <p14:creationId xmlns:p14="http://schemas.microsoft.com/office/powerpoint/2010/main" val="3698167893"/>
       </p:ext>
     </p:extLst>
   </p:cSld>
@@ -867,7 +666,6 @@
               <a:rPr lang="en-US" dirty="0"/>
               <a:t>Month 5 of 12. Headline: the month became an audit-then-rebuild. We found seven defects that invalidated earlier results, fixed all of them, and then went back and closed three deliverables from Months 1-4 that had never been started.</a:t>
             </a:r>
-            <a:endParaRPr lang="en-US" dirty="0"/>
           </a:p>
         </p:txBody>
       </p:sp>
@@ -955,7 +753,6 @@
               <a:rPr lang="en-US" dirty="0"/>
               <a:t>Being explicit here is deliberate. Every one of these has a dated plan attached. Raising them ourselves is better than having them found in review.</a:t>
             </a:r>
-            <a:endParaRPr lang="en-US" dirty="0"/>
           </a:p>
         </p:txBody>
       </p:sp>
@@ -1043,7 +840,6 @@
               <a:rPr lang="en-US" dirty="0"/>
               <a:t>This is the ask. The Pi is the important half - it is inexpensive and it unblocks the work now, while the automotive board is sourced. Without a board, months 7-12 (hardware-in-the-loop, power audit) cannot start either.</a:t>
             </a:r>
-            <a:endParaRPr lang="en-US" dirty="0"/>
           </a:p>
         </p:txBody>
       </p:sp>
@@ -1131,7 +927,6 @@
               <a:rPr lang="en-US" dirty="0"/>
               <a:t>OpenFHE is the biggest single item and the most important. Until it lands we should not describe the system as full multi-key CKKS in any writeup.</a:t>
             </a:r>
-            <a:endParaRPr lang="en-US" dirty="0"/>
           </a:p>
         </p:txBody>
       </p:sp>
@@ -1219,7 +1014,6 @@
               <a:rPr lang="en-US" dirty="0"/>
               <a:t>Close on the ask. Everything else is on track and documented; the board is the one decision we need from this meeting.</a:t>
             </a:r>
-            <a:endParaRPr lang="en-US" dirty="0"/>
           </a:p>
         </p:txBody>
       </p:sp>
@@ -1307,7 +1101,6 @@
               <a:rPr lang="en-US" dirty="0"/>
               <a:t>Lead with this slide. Four numbers, then the headline. The one blocker is that no hardware has been ordered - everything else on the embedded track is now software-complete and waiting on a board.</a:t>
             </a:r>
-            <a:endParaRPr lang="en-US" dirty="0"/>
           </a:p>
         </p:txBody>
       </p:sp>
@@ -1395,7 +1188,6 @@
               <a:rPr lang="en-US" dirty="0"/>
               <a:t>Be straightforward about this. Finding the defects was the valuable part - had we built multi-key CKKS on top of a leaky pipeline we would have produced a cryptographically elegant result about nothing.</a:t>
             </a:r>
-            <a:endParaRPr lang="en-US" dirty="0"/>
           </a:p>
         </p:txBody>
       </p:sp>
@@ -1483,7 +1275,6 @@
               <a:rPr lang="en-US" dirty="0"/>
               <a:t>D4 is the one to emphasise: the deck said the server never sees plaintext, and the code decrypted every client's full 44,164-parameter update every round. That is now a machine-checked invariant, asserted after every round.</a:t>
             </a:r>
-            <a:endParaRPr lang="en-US" dirty="0"/>
           </a:p>
         </p:txBody>
       </p:sp>
@@ -1571,7 +1362,6 @@
               <a:rPr lang="en-US" dirty="0"/>
               <a:t>The Month-4 setup was structurally incapable of answering this question, because its simulated encryption injected noise that sent the two arms down different training trajectories. This is the first controlled version of the comparison.</a:t>
             </a:r>
-            <a:endParaRPr lang="en-US" dirty="0"/>
           </a:p>
         </p:txBody>
       </p:sp>
@@ -1659,7 +1449,6 @@
               <a:rPr lang="en-US" dirty="0"/>
               <a:t>If asked why VeReMi is low: we measured it before training. Best single-feature class separation is 0.046 standard deviations - the features cannot express the task. Training then confirmed it at ROC-AUC 0.516.</a:t>
             </a:r>
-            <a:endParaRPr lang="en-US" dirty="0"/>
           </a:p>
         </p:txBody>
       </p:sp>
@@ -1747,7 +1536,6 @@
               <a:rPr lang="en-US" dirty="0"/>
               <a:t>Point D is our own contribution beyond the paper. FheFL samples a random subset of users each round but generates pairwise secrets once at enrolment - so any dropout breaks decryption silently. For a vehicle fleet that is the normal case, not an edge case.</a:t>
             </a:r>
-            <a:endParaRPr lang="en-US" dirty="0"/>
           </a:p>
         </p:txBody>
       </p:sp>
@@ -1835,7 +1623,6 @@
               <a:rPr lang="en-US" dirty="0"/>
               <a:t>These were genuinely not started before this month. The packing win came from reading the protocol rather than the cryptography - the server's two operations act on independent copies of each ciphertext, so the update only needs one multiplicative level, not two.</a:t>
             </a:r>
-            <a:endParaRPr lang="en-US" dirty="0"/>
           </a:p>
         </p:txBody>
       </p:sp>
@@ -1923,7 +1710,6 @@
               <a:rPr lang="en-US" dirty="0"/>
               <a:t>The NTT lesson transfers directly to the embedded port: performance is governed by memory access pattern and per-operation overhead, not by the butterfly arithmetic. That is why the production kernel needs contiguous SIMD lanes rather than a literal transcription of the pseudocode.</a:t>
             </a:r>
-            <a:endParaRPr lang="en-US" dirty="0"/>
           </a:p>
         </p:txBody>
       </p:sp>
@@ -1996,6 +1782,11 @@
 <file path=ppt/slideMasters/slideMaster1.xml><?xml version="1.0" encoding="utf-8"?>
 <p:sldMaster xmlns:a="http://schemas.openxmlformats.org/drawingml/2006/main" xmlns:r="http://schemas.openxmlformats.org/officeDocument/2006/relationships" xmlns:p="http://schemas.openxmlformats.org/presentationml/2006/main">
   <p:cSld>
+    <p:bg>
+      <p:bgRef idx="1001">
+        <a:schemeClr val="bg1"/>
+      </p:bgRef>
+    </p:bg>
     <p:spTree>
       <p:nvGrpSpPr>
         <p:cNvPr id="1" name=""/>
@@ -2278,6 +2069,7 @@
         <a:solidFill>
           <a:srgbClr val="1E2761"/>
         </a:solidFill>
+        <a:effectLst/>
       </p:bgPr>
     </p:bg>
     <p:spTree>
@@ -2315,11 +2107,11 @@
           <a:bodyPr wrap="square" rtlCol="0" anchor="ctr"/>
           <a:lstStyle/>
           <a:p>
-            <a:pPr indent="0" marL="0">
+            <a:pPr marL="0" indent="0">
               <a:buNone/>
             </a:pPr>
             <a:r>
-              <a:rPr lang="en-US" sz="1400" b="1" spc="300" kern="0" dirty="0">
+              <a:rPr lang="en-US" sz="1400" b="1" kern="0" spc="300" dirty="0">
                 <a:solidFill>
                   <a:srgbClr val="CADCFC"/>
                 </a:solidFill>
@@ -2354,7 +2146,7 @@
           <a:bodyPr wrap="square" rtlCol="0" anchor="ctr"/>
           <a:lstStyle/>
           <a:p>
-            <a:pPr indent="0" marL="0">
+            <a:pPr marL="0" indent="0">
               <a:lnSpc>
                 <a:spcPts val="4600"/>
               </a:lnSpc>
@@ -2374,7 +2166,7 @@
             <a:endParaRPr lang="en-US" sz="4000" dirty="0"/>
           </a:p>
           <a:p>
-            <a:pPr indent="0" marL="0">
+            <a:pPr marL="0" indent="0">
               <a:lnSpc>
                 <a:spcPts val="4600"/>
               </a:lnSpc>
@@ -2416,7 +2208,7 @@
           <a:bodyPr wrap="square" rtlCol="0" anchor="ctr"/>
           <a:lstStyle/>
           <a:p>
-            <a:pPr indent="0" marL="0">
+            <a:pPr marL="0" indent="0">
               <a:lnSpc>
                 <a:spcPts val="2400"/>
               </a:lnSpc>
@@ -2436,7 +2228,7 @@
             <a:endParaRPr lang="en-US" sz="1600" dirty="0"/>
           </a:p>
           <a:p>
-            <a:pPr indent="0" marL="0">
+            <a:pPr marL="0" indent="0">
               <a:lnSpc>
                 <a:spcPts val="2400"/>
               </a:lnSpc>
@@ -2498,7 +2290,7 @@
           <a:bodyPr wrap="square" lIns="0" tIns="0" rIns="0" bIns="0" rtlCol="0" anchor="ctr"/>
           <a:lstStyle/>
           <a:p>
-            <a:pPr indent="0" marL="0">
+            <a:pPr marL="0" indent="0">
               <a:buNone/>
             </a:pPr>
             <a:r>
@@ -2532,6 +2324,7 @@
         <a:solidFill>
           <a:srgbClr val="FFFFFF"/>
         </a:solidFill>
+        <a:effectLst/>
       </p:bgPr>
     </p:bg>
     <p:spTree>
@@ -2569,7 +2362,7 @@
           <a:bodyPr wrap="square" lIns="0" tIns="0" rIns="0" bIns="0" rtlCol="0" anchor="ctr"/>
           <a:lstStyle/>
           <a:p>
-            <a:pPr indent="0" marL="0">
+            <a:pPr marL="0" indent="0">
               <a:buNone/>
             </a:pPr>
             <a:r>
@@ -2608,7 +2401,7 @@
           <a:bodyPr wrap="square" lIns="0" tIns="0" rIns="0" bIns="0" rtlCol="0" anchor="ctr"/>
           <a:lstStyle/>
           <a:p>
-            <a:pPr indent="0" marL="0">
+            <a:pPr marL="0" indent="0">
               <a:buNone/>
             </a:pPr>
             <a:r>
@@ -2667,7 +2460,7 @@
           <a:bodyPr wrap="square" lIns="0" tIns="0" rIns="0" bIns="0" rtlCol="0" anchor="ctr"/>
           <a:lstStyle/>
           <a:p>
-            <a:pPr algn="ctr" indent="0" marL="0">
+            <a:pPr marL="0" indent="0" algn="ctr">
               <a:buNone/>
             </a:pPr>
             <a:r>
@@ -2706,7 +2499,7 @@
           <a:bodyPr wrap="square" lIns="0" tIns="0" rIns="0" bIns="0" rtlCol="0" anchor="ctr"/>
           <a:lstStyle/>
           <a:p>
-            <a:pPr indent="0" marL="0">
+            <a:pPr marL="0" indent="0">
               <a:buNone/>
             </a:pPr>
             <a:r>
@@ -2745,7 +2538,7 @@
           <a:bodyPr wrap="square" lIns="0" tIns="0" rIns="0" bIns="0" rtlCol="0" anchor="ctr"/>
           <a:lstStyle/>
           <a:p>
-            <a:pPr indent="0" marL="0">
+            <a:pPr marL="0" indent="0">
               <a:lnSpc>
                 <a:spcPts val="1500"/>
               </a:lnSpc>
@@ -2807,7 +2600,7 @@
           <a:bodyPr wrap="square" lIns="0" tIns="0" rIns="0" bIns="0" rtlCol="0" anchor="ctr"/>
           <a:lstStyle/>
           <a:p>
-            <a:pPr algn="ctr" indent="0" marL="0">
+            <a:pPr marL="0" indent="0" algn="ctr">
               <a:buNone/>
             </a:pPr>
             <a:r>
@@ -2846,7 +2639,7 @@
           <a:bodyPr wrap="square" lIns="0" tIns="0" rIns="0" bIns="0" rtlCol="0" anchor="ctr"/>
           <a:lstStyle/>
           <a:p>
-            <a:pPr indent="0" marL="0">
+            <a:pPr marL="0" indent="0">
               <a:buNone/>
             </a:pPr>
             <a:r>
@@ -2885,7 +2678,7 @@
           <a:bodyPr wrap="square" lIns="0" tIns="0" rIns="0" bIns="0" rtlCol="0" anchor="ctr"/>
           <a:lstStyle/>
           <a:p>
-            <a:pPr indent="0" marL="0">
+            <a:pPr marL="0" indent="0">
               <a:lnSpc>
                 <a:spcPts val="1500"/>
               </a:lnSpc>
@@ -2947,7 +2740,7 @@
           <a:bodyPr wrap="square" lIns="0" tIns="0" rIns="0" bIns="0" rtlCol="0" anchor="ctr"/>
           <a:lstStyle/>
           <a:p>
-            <a:pPr algn="ctr" indent="0" marL="0">
+            <a:pPr marL="0" indent="0" algn="ctr">
               <a:buNone/>
             </a:pPr>
             <a:r>
@@ -2986,7 +2779,7 @@
           <a:bodyPr wrap="square" lIns="0" tIns="0" rIns="0" bIns="0" rtlCol="0" anchor="ctr"/>
           <a:lstStyle/>
           <a:p>
-            <a:pPr indent="0" marL="0">
+            <a:pPr marL="0" indent="0">
               <a:buNone/>
             </a:pPr>
             <a:r>
@@ -3025,7 +2818,7 @@
           <a:bodyPr wrap="square" lIns="0" tIns="0" rIns="0" bIns="0" rtlCol="0" anchor="ctr"/>
           <a:lstStyle/>
           <a:p>
-            <a:pPr indent="0" marL="0">
+            <a:pPr marL="0" indent="0">
               <a:lnSpc>
                 <a:spcPts val="1500"/>
               </a:lnSpc>
@@ -3087,7 +2880,7 @@
           <a:bodyPr wrap="square" lIns="0" tIns="0" rIns="0" bIns="0" rtlCol="0" anchor="ctr"/>
           <a:lstStyle/>
           <a:p>
-            <a:pPr algn="ctr" indent="0" marL="0">
+            <a:pPr marL="0" indent="0" algn="ctr">
               <a:buNone/>
             </a:pPr>
             <a:r>
@@ -3126,7 +2919,7 @@
           <a:bodyPr wrap="square" lIns="0" tIns="0" rIns="0" bIns="0" rtlCol="0" anchor="ctr"/>
           <a:lstStyle/>
           <a:p>
-            <a:pPr indent="0" marL="0">
+            <a:pPr marL="0" indent="0">
               <a:buNone/>
             </a:pPr>
             <a:r>
@@ -3165,7 +2958,7 @@
           <a:bodyPr wrap="square" lIns="0" tIns="0" rIns="0" bIns="0" rtlCol="0" anchor="ctr"/>
           <a:lstStyle/>
           <a:p>
-            <a:pPr indent="0" marL="0">
+            <a:pPr marL="0" indent="0">
               <a:lnSpc>
                 <a:spcPts val="1500"/>
               </a:lnSpc>
@@ -3202,6 +2995,7 @@
         <a:solidFill>
           <a:srgbClr val="1E2761"/>
         </a:solidFill>
+        <a:effectLst/>
       </p:bgPr>
     </p:bg>
     <p:spTree>
@@ -3239,7 +3033,7 @@
           <a:bodyPr wrap="square" lIns="0" tIns="0" rIns="0" bIns="0" rtlCol="0" anchor="ctr"/>
           <a:lstStyle/>
           <a:p>
-            <a:pPr indent="0" marL="0">
+            <a:pPr marL="0" indent="0">
               <a:buNone/>
             </a:pPr>
             <a:r>
@@ -3278,7 +3072,7 @@
           <a:bodyPr wrap="square" lIns="0" tIns="0" rIns="0" bIns="0" rtlCol="0" anchor="ctr"/>
           <a:lstStyle/>
           <a:p>
-            <a:pPr indent="0" marL="0">
+            <a:pPr marL="0" indent="0">
               <a:buNone/>
             </a:pPr>
             <a:r>
@@ -3344,7 +3138,7 @@
           <a:bodyPr wrap="square" lIns="0" tIns="0" rIns="0" bIns="0" rtlCol="0" anchor="ctr"/>
           <a:lstStyle/>
           <a:p>
-            <a:pPr indent="0" marL="0">
+            <a:pPr marL="0" indent="0">
               <a:buNone/>
             </a:pPr>
             <a:r>
@@ -3383,7 +3177,7 @@
           <a:bodyPr wrap="square" lIns="0" tIns="0" rIns="0" bIns="0" rtlCol="0" anchor="ctr"/>
           <a:lstStyle/>
           <a:p>
-            <a:pPr indent="0" marL="0">
+            <a:pPr marL="0" indent="0">
               <a:buNone/>
             </a:pPr>
             <a:r>
@@ -3422,11 +3216,11 @@
           <a:bodyPr wrap="square" lIns="0" tIns="0" rIns="0" bIns="0" rtlCol="0" anchor="ctr"/>
           <a:lstStyle/>
           <a:p>
-            <a:pPr indent="0" marL="0">
+            <a:pPr marL="0" indent="0">
               <a:buNone/>
             </a:pPr>
             <a:r>
-              <a:rPr lang="en-US" sz="1200" b="1" spc="150" kern="0" dirty="0">
+              <a:rPr lang="en-US" sz="1200" b="1" kern="0" spc="150" dirty="0">
                 <a:solidFill>
                   <a:srgbClr val="CADCFC"/>
                 </a:solidFill>
@@ -3488,7 +3282,7 @@
           <a:bodyPr wrap="square" lIns="0" tIns="0" rIns="0" bIns="0" rtlCol="0" anchor="ctr"/>
           <a:lstStyle/>
           <a:p>
-            <a:pPr indent="0" marL="0">
+            <a:pPr marL="0" indent="0">
               <a:buNone/>
             </a:pPr>
             <a:r>
@@ -3527,7 +3321,7 @@
           <a:bodyPr wrap="square" lIns="0" tIns="0" rIns="0" bIns="0" rtlCol="0" anchor="ctr"/>
           <a:lstStyle/>
           <a:p>
-            <a:pPr indent="0" marL="0">
+            <a:pPr marL="0" indent="0">
               <a:lnSpc>
                 <a:spcPts val="1700"/>
               </a:lnSpc>
@@ -3596,7 +3390,7 @@
           <a:bodyPr wrap="square" lIns="0" tIns="0" rIns="0" bIns="0" rtlCol="0" anchor="ctr"/>
           <a:lstStyle/>
           <a:p>
-            <a:pPr indent="0" marL="0">
+            <a:pPr marL="0" indent="0">
               <a:buNone/>
             </a:pPr>
             <a:r>
@@ -3635,7 +3429,7 @@
           <a:bodyPr wrap="square" lIns="0" tIns="0" rIns="0" bIns="0" rtlCol="0" anchor="ctr"/>
           <a:lstStyle/>
           <a:p>
-            <a:pPr indent="0" marL="0">
+            <a:pPr marL="0" indent="0">
               <a:lnSpc>
                 <a:spcPts val="1700"/>
               </a:lnSpc>
@@ -3672,6 +3466,7 @@
         <a:solidFill>
           <a:srgbClr val="FFFFFF"/>
         </a:solidFill>
+        <a:effectLst/>
       </p:bgPr>
     </p:bg>
     <p:spTree>
@@ -3709,7 +3504,7 @@
           <a:bodyPr wrap="square" lIns="0" tIns="0" rIns="0" bIns="0" rtlCol="0" anchor="ctr"/>
           <a:lstStyle/>
           <a:p>
-            <a:pPr indent="0" marL="0">
+            <a:pPr marL="0" indent="0">
               <a:buNone/>
             </a:pPr>
             <a:r>
@@ -3748,7 +3543,7 @@
           <a:bodyPr wrap="square" lIns="0" tIns="0" rIns="0" bIns="0" rtlCol="0" anchor="ctr"/>
           <a:lstStyle/>
           <a:p>
-            <a:pPr indent="0" marL="0">
+            <a:pPr marL="0" indent="0">
               <a:buNone/>
             </a:pPr>
             <a:r>
@@ -3782,17 +3577,41 @@
         </p:nvGraphicFramePr>
         <p:xfrm>
           <a:off x="640080" y="1481328"/>
-          <a:ext cx="10881360" cy="914400"/>
+          <a:ext cx="10881360" cy="3328416"/>
         </p:xfrm>
         <a:graphic>
           <a:graphicData uri="http://schemas.openxmlformats.org/drawingml/2006/table">
             <a:tbl>
               <a:tblPr/>
               <a:tblGrid>
-                <a:gridCol w="1051560"/>
-                <a:gridCol w="4434840"/>
-                <a:gridCol w="1188720"/>
-                <a:gridCol w="4206240"/>
+                <a:gridCol w="1051560">
+                  <a:extLst>
+                    <a:ext uri="{9D8B030D-6E8A-4147-A177-3AD203B41FA5}">
+                      <a16:colId xmlns:a16="http://schemas.microsoft.com/office/drawing/2014/main" val="20000"/>
+                    </a:ext>
+                  </a:extLst>
+                </a:gridCol>
+                <a:gridCol w="4434840">
+                  <a:extLst>
+                    <a:ext uri="{9D8B030D-6E8A-4147-A177-3AD203B41FA5}">
+                      <a16:colId xmlns:a16="http://schemas.microsoft.com/office/drawing/2014/main" val="20001"/>
+                    </a:ext>
+                  </a:extLst>
+                </a:gridCol>
+                <a:gridCol w="1188720">
+                  <a:extLst>
+                    <a:ext uri="{9D8B030D-6E8A-4147-A177-3AD203B41FA5}">
+                      <a16:colId xmlns:a16="http://schemas.microsoft.com/office/drawing/2014/main" val="20002"/>
+                    </a:ext>
+                  </a:extLst>
+                </a:gridCol>
+                <a:gridCol w="4206240">
+                  <a:extLst>
+                    <a:ext uri="{9D8B030D-6E8A-4147-A177-3AD203B41FA5}">
+                      <a16:colId xmlns:a16="http://schemas.microsoft.com/office/drawing/2014/main" val="20003"/>
+                    </a:ext>
+                  </a:extLst>
+                </a:gridCol>
               </a:tblGrid>
               <a:tr h="475488">
                 <a:tc>
@@ -3800,7 +3619,7 @@
                     <a:bodyPr/>
                     <a:lstStyle/>
                     <a:p>
-                      <a:pPr indent="0" marL="0">
+                      <a:pPr marL="0" indent="0">
                         <a:buNone/>
                       </a:pPr>
                       <a:r>
@@ -3821,7 +3640,7 @@
                       </a:endParaRPr>
                     </a:p>
                   </a:txBody>
-                  <a:tcPr marL="91440" marR="91440" marT="45720" marB="45720" anchor="ctr">
+                  <a:tcPr anchor="ctr">
                     <a:lnL w="12700" cap="flat" cmpd="sng" algn="ctr">
                       <a:solidFill>
                         <a:srgbClr val="E1E8F2"/>
@@ -3868,7 +3687,7 @@
                     <a:bodyPr/>
                     <a:lstStyle/>
                     <a:p>
-                      <a:pPr indent="0" marL="0">
+                      <a:pPr marL="0" indent="0">
                         <a:buNone/>
                       </a:pPr>
                       <a:r>
@@ -3889,7 +3708,7 @@
                       </a:endParaRPr>
                     </a:p>
                   </a:txBody>
-                  <a:tcPr marL="91440" marR="91440" marT="45720" marB="45720" anchor="ctr">
+                  <a:tcPr anchor="ctr">
                     <a:lnL w="12700" cap="flat" cmpd="sng" algn="ctr">
                       <a:solidFill>
                         <a:srgbClr val="E1E8F2"/>
@@ -3936,7 +3755,7 @@
                     <a:bodyPr/>
                     <a:lstStyle/>
                     <a:p>
-                      <a:pPr indent="0" marL="0">
+                      <a:pPr marL="0" indent="0">
                         <a:buNone/>
                       </a:pPr>
                       <a:r>
@@ -3957,7 +3776,7 @@
                       </a:endParaRPr>
                     </a:p>
                   </a:txBody>
-                  <a:tcPr marL="91440" marR="91440" marT="45720" marB="45720" anchor="ctr">
+                  <a:tcPr anchor="ctr">
                     <a:lnL w="12700" cap="flat" cmpd="sng" algn="ctr">
                       <a:solidFill>
                         <a:srgbClr val="E1E8F2"/>
@@ -4004,7 +3823,7 @@
                     <a:bodyPr/>
                     <a:lstStyle/>
                     <a:p>
-                      <a:pPr indent="0" marL="0">
+                      <a:pPr marL="0" indent="0">
                         <a:buNone/>
                       </a:pPr>
                       <a:r>
@@ -4025,7 +3844,7 @@
                       </a:endParaRPr>
                     </a:p>
                   </a:txBody>
-                  <a:tcPr marL="91440" marR="91440" marT="45720" marB="45720" anchor="ctr">
+                  <a:tcPr anchor="ctr">
                     <a:lnL w="12700" cap="flat" cmpd="sng" algn="ctr">
                       <a:solidFill>
                         <a:srgbClr val="E1E8F2"/>
@@ -4067,6 +3886,11 @@
                     </a:solidFill>
                   </a:tcPr>
                 </a:tc>
+                <a:extLst>
+                  <a:ext uri="{0D108BD9-81ED-4DB2-BD59-A6C34878D82A}">
+                    <a16:rowId xmlns:a16="http://schemas.microsoft.com/office/drawing/2014/main" val="10000"/>
+                  </a:ext>
+                </a:extLst>
               </a:tr>
               <a:tr h="475488">
                 <a:tc>
@@ -4074,7 +3898,7 @@
                     <a:bodyPr/>
                     <a:lstStyle/>
                     <a:p>
-                      <a:pPr indent="0" marL="0">
+                      <a:pPr marL="0" indent="0">
                         <a:buNone/>
                       </a:pPr>
                       <a:r>
@@ -4095,7 +3919,7 @@
                       </a:endParaRPr>
                     </a:p>
                   </a:txBody>
-                  <a:tcPr marL="91440" marR="91440" marT="45720" marB="45720" anchor="ctr">
+                  <a:tcPr anchor="ctr">
                     <a:lnL w="12700" cap="flat" cmpd="sng" algn="ctr">
                       <a:solidFill>
                         <a:srgbClr val="E1E8F2"/>
@@ -4139,7 +3963,7 @@
                     <a:bodyPr/>
                     <a:lstStyle/>
                     <a:p>
-                      <a:pPr indent="0" marL="0">
+                      <a:pPr marL="0" indent="0">
                         <a:buNone/>
                       </a:pPr>
                       <a:r>
@@ -4160,7 +3984,7 @@
                       </a:endParaRPr>
                     </a:p>
                   </a:txBody>
-                  <a:tcPr marL="91440" marR="91440" marT="45720" marB="45720" anchor="ctr">
+                  <a:tcPr anchor="ctr">
                     <a:lnL w="12700" cap="flat" cmpd="sng" algn="ctr">
                       <a:solidFill>
                         <a:srgbClr val="E1E8F2"/>
@@ -4204,7 +4028,7 @@
                     <a:bodyPr/>
                     <a:lstStyle/>
                     <a:p>
-                      <a:pPr indent="0" marL="0">
+                      <a:pPr marL="0" indent="0">
                         <a:buNone/>
                       </a:pPr>
                       <a:r>
@@ -4225,7 +4049,7 @@
                       </a:endParaRPr>
                     </a:p>
                   </a:txBody>
-                  <a:tcPr marL="91440" marR="91440" marT="45720" marB="45720" anchor="ctr">
+                  <a:tcPr anchor="ctr">
                     <a:lnL w="12700" cap="flat" cmpd="sng" algn="ctr">
                       <a:solidFill>
                         <a:srgbClr val="E1E8F2"/>
@@ -4269,7 +4093,7 @@
                     <a:bodyPr/>
                     <a:lstStyle/>
                     <a:p>
-                      <a:pPr indent="0" marL="0">
+                      <a:pPr marL="0" indent="0">
                         <a:buNone/>
                       </a:pPr>
                       <a:r>
@@ -4290,7 +4114,7 @@
                       </a:endParaRPr>
                     </a:p>
                   </a:txBody>
-                  <a:tcPr marL="91440" marR="91440" marT="45720" marB="45720" anchor="ctr">
+                  <a:tcPr anchor="ctr">
                     <a:lnL w="12700" cap="flat" cmpd="sng" algn="ctr">
                       <a:solidFill>
                         <a:srgbClr val="E1E8F2"/>
@@ -4329,6 +4153,11 @@
                     </a:lnB>
                   </a:tcPr>
                 </a:tc>
+                <a:extLst>
+                  <a:ext uri="{0D108BD9-81ED-4DB2-BD59-A6C34878D82A}">
+                    <a16:rowId xmlns:a16="http://schemas.microsoft.com/office/drawing/2014/main" val="10001"/>
+                  </a:ext>
+                </a:extLst>
               </a:tr>
               <a:tr h="475488">
                 <a:tc>
@@ -4336,7 +4165,7 @@
                     <a:bodyPr/>
                     <a:lstStyle/>
                     <a:p>
-                      <a:pPr indent="0" marL="0">
+                      <a:pPr marL="0" indent="0">
                         <a:buNone/>
                       </a:pPr>
                       <a:r>
@@ -4357,7 +4186,7 @@
                       </a:endParaRPr>
                     </a:p>
                   </a:txBody>
-                  <a:tcPr marL="91440" marR="91440" marT="45720" marB="45720" anchor="ctr">
+                  <a:tcPr anchor="ctr">
                     <a:lnL w="12700" cap="flat" cmpd="sng" algn="ctr">
                       <a:solidFill>
                         <a:srgbClr val="E1E8F2"/>
@@ -4401,7 +4230,7 @@
                     <a:bodyPr/>
                     <a:lstStyle/>
                     <a:p>
-                      <a:pPr indent="0" marL="0">
+                      <a:pPr marL="0" indent="0">
                         <a:buNone/>
                       </a:pPr>
                       <a:r>
@@ -4422,7 +4251,7 @@
                       </a:endParaRPr>
                     </a:p>
                   </a:txBody>
-                  <a:tcPr marL="91440" marR="91440" marT="45720" marB="45720" anchor="ctr">
+                  <a:tcPr anchor="ctr">
                     <a:lnL w="12700" cap="flat" cmpd="sng" algn="ctr">
                       <a:solidFill>
                         <a:srgbClr val="E1E8F2"/>
@@ -4466,7 +4295,7 @@
                     <a:bodyPr/>
                     <a:lstStyle/>
                     <a:p>
-                      <a:pPr indent="0" marL="0">
+                      <a:pPr marL="0" indent="0">
                         <a:buNone/>
                       </a:pPr>
                       <a:r>
@@ -4487,7 +4316,7 @@
                       </a:endParaRPr>
                     </a:p>
                   </a:txBody>
-                  <a:tcPr marL="91440" marR="91440" marT="45720" marB="45720" anchor="ctr">
+                  <a:tcPr anchor="ctr">
                     <a:lnL w="12700" cap="flat" cmpd="sng" algn="ctr">
                       <a:solidFill>
                         <a:srgbClr val="E1E8F2"/>
@@ -4531,7 +4360,7 @@
                     <a:bodyPr/>
                     <a:lstStyle/>
                     <a:p>
-                      <a:pPr indent="0" marL="0">
+                      <a:pPr marL="0" indent="0">
                         <a:buNone/>
                       </a:pPr>
                       <a:r>
@@ -4552,7 +4381,7 @@
                       </a:endParaRPr>
                     </a:p>
                   </a:txBody>
-                  <a:tcPr marL="91440" marR="91440" marT="45720" marB="45720" anchor="ctr">
+                  <a:tcPr anchor="ctr">
                     <a:lnL w="12700" cap="flat" cmpd="sng" algn="ctr">
                       <a:solidFill>
                         <a:srgbClr val="E1E8F2"/>
@@ -4591,6 +4420,11 @@
                     </a:lnB>
                   </a:tcPr>
                 </a:tc>
+                <a:extLst>
+                  <a:ext uri="{0D108BD9-81ED-4DB2-BD59-A6C34878D82A}">
+                    <a16:rowId xmlns:a16="http://schemas.microsoft.com/office/drawing/2014/main" val="10002"/>
+                  </a:ext>
+                </a:extLst>
               </a:tr>
               <a:tr h="475488">
                 <a:tc>
@@ -4598,7 +4432,7 @@
                     <a:bodyPr/>
                     <a:lstStyle/>
                     <a:p>
-                      <a:pPr indent="0" marL="0">
+                      <a:pPr marL="0" indent="0">
                         <a:buNone/>
                       </a:pPr>
                       <a:r>
@@ -4619,7 +4453,7 @@
                       </a:endParaRPr>
                     </a:p>
                   </a:txBody>
-                  <a:tcPr marL="91440" marR="91440" marT="45720" marB="45720" anchor="ctr">
+                  <a:tcPr anchor="ctr">
                     <a:lnL w="12700" cap="flat" cmpd="sng" algn="ctr">
                       <a:solidFill>
                         <a:srgbClr val="E1E8F2"/>
@@ -4663,7 +4497,7 @@
                     <a:bodyPr/>
                     <a:lstStyle/>
                     <a:p>
-                      <a:pPr indent="0" marL="0">
+                      <a:pPr marL="0" indent="0">
                         <a:buNone/>
                       </a:pPr>
                       <a:r>
@@ -4684,7 +4518,7 @@
                       </a:endParaRPr>
                     </a:p>
                   </a:txBody>
-                  <a:tcPr marL="91440" marR="91440" marT="45720" marB="45720" anchor="ctr">
+                  <a:tcPr anchor="ctr">
                     <a:lnL w="12700" cap="flat" cmpd="sng" algn="ctr">
                       <a:solidFill>
                         <a:srgbClr val="E1E8F2"/>
@@ -4728,7 +4562,7 @@
                     <a:bodyPr/>
                     <a:lstStyle/>
                     <a:p>
-                      <a:pPr indent="0" marL="0">
+                      <a:pPr marL="0" indent="0">
                         <a:buNone/>
                       </a:pPr>
                       <a:r>
@@ -4749,7 +4583,7 @@
                       </a:endParaRPr>
                     </a:p>
                   </a:txBody>
-                  <a:tcPr marL="91440" marR="91440" marT="45720" marB="45720" anchor="ctr">
+                  <a:tcPr anchor="ctr">
                     <a:lnL w="12700" cap="flat" cmpd="sng" algn="ctr">
                       <a:solidFill>
                         <a:srgbClr val="E1E8F2"/>
@@ -4793,7 +4627,7 @@
                     <a:bodyPr/>
                     <a:lstStyle/>
                     <a:p>
-                      <a:pPr indent="0" marL="0">
+                      <a:pPr marL="0" indent="0">
                         <a:buNone/>
                       </a:pPr>
                       <a:r>
@@ -4814,7 +4648,7 @@
                       </a:endParaRPr>
                     </a:p>
                   </a:txBody>
-                  <a:tcPr marL="91440" marR="91440" marT="45720" marB="45720" anchor="ctr">
+                  <a:tcPr anchor="ctr">
                     <a:lnL w="12700" cap="flat" cmpd="sng" algn="ctr">
                       <a:solidFill>
                         <a:srgbClr val="E1E8F2"/>
@@ -4853,6 +4687,11 @@
                     </a:lnB>
                   </a:tcPr>
                 </a:tc>
+                <a:extLst>
+                  <a:ext uri="{0D108BD9-81ED-4DB2-BD59-A6C34878D82A}">
+                    <a16:rowId xmlns:a16="http://schemas.microsoft.com/office/drawing/2014/main" val="10003"/>
+                  </a:ext>
+                </a:extLst>
               </a:tr>
               <a:tr h="475488">
                 <a:tc>
@@ -4860,7 +4699,7 @@
                     <a:bodyPr/>
                     <a:lstStyle/>
                     <a:p>
-                      <a:pPr indent="0" marL="0">
+                      <a:pPr marL="0" indent="0">
                         <a:buNone/>
                       </a:pPr>
                       <a:r>
@@ -4881,7 +4720,7 @@
                       </a:endParaRPr>
                     </a:p>
                   </a:txBody>
-                  <a:tcPr marL="91440" marR="91440" marT="45720" marB="45720" anchor="ctr">
+                  <a:tcPr anchor="ctr">
                     <a:lnL w="12700" cap="flat" cmpd="sng" algn="ctr">
                       <a:solidFill>
                         <a:srgbClr val="E1E8F2"/>
@@ -4925,7 +4764,7 @@
                     <a:bodyPr/>
                     <a:lstStyle/>
                     <a:p>
-                      <a:pPr indent="0" marL="0">
+                      <a:pPr marL="0" indent="0">
                         <a:buNone/>
                       </a:pPr>
                       <a:r>
@@ -4946,7 +4785,7 @@
                       </a:endParaRPr>
                     </a:p>
                   </a:txBody>
-                  <a:tcPr marL="91440" marR="91440" marT="45720" marB="45720" anchor="ctr">
+                  <a:tcPr anchor="ctr">
                     <a:lnL w="12700" cap="flat" cmpd="sng" algn="ctr">
                       <a:solidFill>
                         <a:srgbClr val="E1E8F2"/>
@@ -4990,7 +4829,7 @@
                     <a:bodyPr/>
                     <a:lstStyle/>
                     <a:p>
-                      <a:pPr indent="0" marL="0">
+                      <a:pPr marL="0" indent="0">
                         <a:buNone/>
                       </a:pPr>
                       <a:r>
@@ -5011,7 +4850,7 @@
                       </a:endParaRPr>
                     </a:p>
                   </a:txBody>
-                  <a:tcPr marL="91440" marR="91440" marT="45720" marB="45720" anchor="ctr">
+                  <a:tcPr anchor="ctr">
                     <a:lnL w="12700" cap="flat" cmpd="sng" algn="ctr">
                       <a:solidFill>
                         <a:srgbClr val="E1E8F2"/>
@@ -5055,7 +4894,7 @@
                     <a:bodyPr/>
                     <a:lstStyle/>
                     <a:p>
-                      <a:pPr indent="0" marL="0">
+                      <a:pPr marL="0" indent="0">
                         <a:buNone/>
                       </a:pPr>
                       <a:r>
@@ -5076,7 +4915,7 @@
                       </a:endParaRPr>
                     </a:p>
                   </a:txBody>
-                  <a:tcPr marL="91440" marR="91440" marT="45720" marB="45720" anchor="ctr">
+                  <a:tcPr anchor="ctr">
                     <a:lnL w="12700" cap="flat" cmpd="sng" algn="ctr">
                       <a:solidFill>
                         <a:srgbClr val="E1E8F2"/>
@@ -5115,6 +4954,11 @@
                     </a:lnB>
                   </a:tcPr>
                 </a:tc>
+                <a:extLst>
+                  <a:ext uri="{0D108BD9-81ED-4DB2-BD59-A6C34878D82A}">
+                    <a16:rowId xmlns:a16="http://schemas.microsoft.com/office/drawing/2014/main" val="10004"/>
+                  </a:ext>
+                </a:extLst>
               </a:tr>
               <a:tr h="475488">
                 <a:tc>
@@ -5122,7 +4966,7 @@
                     <a:bodyPr/>
                     <a:lstStyle/>
                     <a:p>
-                      <a:pPr indent="0" marL="0">
+                      <a:pPr marL="0" indent="0">
                         <a:buNone/>
                       </a:pPr>
                       <a:r>
@@ -5143,7 +4987,7 @@
                       </a:endParaRPr>
                     </a:p>
                   </a:txBody>
-                  <a:tcPr marL="91440" marR="91440" marT="45720" marB="45720" anchor="ctr">
+                  <a:tcPr anchor="ctr">
                     <a:lnL w="12700" cap="flat" cmpd="sng" algn="ctr">
                       <a:solidFill>
                         <a:srgbClr val="E1E8F2"/>
@@ -5187,7 +5031,7 @@
                     <a:bodyPr/>
                     <a:lstStyle/>
                     <a:p>
-                      <a:pPr indent="0" marL="0">
+                      <a:pPr marL="0" indent="0">
                         <a:buNone/>
                       </a:pPr>
                       <a:r>
@@ -5208,7 +5052,7 @@
                       </a:endParaRPr>
                     </a:p>
                   </a:txBody>
-                  <a:tcPr marL="91440" marR="91440" marT="45720" marB="45720" anchor="ctr">
+                  <a:tcPr anchor="ctr">
                     <a:lnL w="12700" cap="flat" cmpd="sng" algn="ctr">
                       <a:solidFill>
                         <a:srgbClr val="E1E8F2"/>
@@ -5252,7 +5096,7 @@
                     <a:bodyPr/>
                     <a:lstStyle/>
                     <a:p>
-                      <a:pPr indent="0" marL="0">
+                      <a:pPr marL="0" indent="0">
                         <a:buNone/>
                       </a:pPr>
                       <a:r>
@@ -5273,7 +5117,7 @@
                       </a:endParaRPr>
                     </a:p>
                   </a:txBody>
-                  <a:tcPr marL="91440" marR="91440" marT="45720" marB="45720" anchor="ctr">
+                  <a:tcPr anchor="ctr">
                     <a:lnL w="12700" cap="flat" cmpd="sng" algn="ctr">
                       <a:solidFill>
                         <a:srgbClr val="E1E8F2"/>
@@ -5317,7 +5161,7 @@
                     <a:bodyPr/>
                     <a:lstStyle/>
                     <a:p>
-                      <a:pPr indent="0" marL="0">
+                      <a:pPr marL="0" indent="0">
                         <a:buNone/>
                       </a:pPr>
                       <a:r>
@@ -5338,7 +5182,7 @@
                       </a:endParaRPr>
                     </a:p>
                   </a:txBody>
-                  <a:tcPr marL="91440" marR="91440" marT="45720" marB="45720" anchor="ctr">
+                  <a:tcPr anchor="ctr">
                     <a:lnL w="12700" cap="flat" cmpd="sng" algn="ctr">
                       <a:solidFill>
                         <a:srgbClr val="E1E8F2"/>
@@ -5377,6 +5221,11 @@
                     </a:lnB>
                   </a:tcPr>
                 </a:tc>
+                <a:extLst>
+                  <a:ext uri="{0D108BD9-81ED-4DB2-BD59-A6C34878D82A}">
+                    <a16:rowId xmlns:a16="http://schemas.microsoft.com/office/drawing/2014/main" val="10005"/>
+                  </a:ext>
+                </a:extLst>
               </a:tr>
               <a:tr h="475488">
                 <a:tc>
@@ -5384,7 +5233,7 @@
                     <a:bodyPr/>
                     <a:lstStyle/>
                     <a:p>
-                      <a:pPr indent="0" marL="0">
+                      <a:pPr marL="0" indent="0">
                         <a:buNone/>
                       </a:pPr>
                       <a:r>
@@ -5405,7 +5254,7 @@
                       </a:endParaRPr>
                     </a:p>
                   </a:txBody>
-                  <a:tcPr marL="91440" marR="91440" marT="45720" marB="45720" anchor="ctr">
+                  <a:tcPr anchor="ctr">
                     <a:lnL w="12700" cap="flat" cmpd="sng" algn="ctr">
                       <a:solidFill>
                         <a:srgbClr val="E1E8F2"/>
@@ -5449,7 +5298,7 @@
                     <a:bodyPr/>
                     <a:lstStyle/>
                     <a:p>
-                      <a:pPr indent="0" marL="0">
+                      <a:pPr marL="0" indent="0">
                         <a:buNone/>
                       </a:pPr>
                       <a:r>
@@ -5470,7 +5319,7 @@
                       </a:endParaRPr>
                     </a:p>
                   </a:txBody>
-                  <a:tcPr marL="91440" marR="91440" marT="45720" marB="45720" anchor="ctr">
+                  <a:tcPr anchor="ctr">
                     <a:lnL w="12700" cap="flat" cmpd="sng" algn="ctr">
                       <a:solidFill>
                         <a:srgbClr val="E1E8F2"/>
@@ -5514,7 +5363,7 @@
                     <a:bodyPr/>
                     <a:lstStyle/>
                     <a:p>
-                      <a:pPr indent="0" marL="0">
+                      <a:pPr marL="0" indent="0">
                         <a:buNone/>
                       </a:pPr>
                       <a:r>
@@ -5535,7 +5384,7 @@
                       </a:endParaRPr>
                     </a:p>
                   </a:txBody>
-                  <a:tcPr marL="91440" marR="91440" marT="45720" marB="45720" anchor="ctr">
+                  <a:tcPr anchor="ctr">
                     <a:lnL w="12700" cap="flat" cmpd="sng" algn="ctr">
                       <a:solidFill>
                         <a:srgbClr val="E1E8F2"/>
@@ -5579,7 +5428,7 @@
                     <a:bodyPr/>
                     <a:lstStyle/>
                     <a:p>
-                      <a:pPr indent="0" marL="0">
+                      <a:pPr marL="0" indent="0">
                         <a:buNone/>
                       </a:pPr>
                       <a:r>
@@ -5600,7 +5449,7 @@
                       </a:endParaRPr>
                     </a:p>
                   </a:txBody>
-                  <a:tcPr marL="91440" marR="91440" marT="45720" marB="45720" anchor="ctr">
+                  <a:tcPr anchor="ctr">
                     <a:lnL w="12700" cap="flat" cmpd="sng" algn="ctr">
                       <a:solidFill>
                         <a:srgbClr val="E1E8F2"/>
@@ -5639,6 +5488,11 @@
                     </a:lnB>
                   </a:tcPr>
                 </a:tc>
+                <a:extLst>
+                  <a:ext uri="{0D108BD9-81ED-4DB2-BD59-A6C34878D82A}">
+                    <a16:rowId xmlns:a16="http://schemas.microsoft.com/office/drawing/2014/main" val="10006"/>
+                  </a:ext>
+                </a:extLst>
               </a:tr>
             </a:tbl>
           </a:graphicData>
@@ -5692,7 +5546,7 @@
           <a:bodyPr wrap="square" lIns="0" tIns="0" rIns="0" bIns="0" rtlCol="0" anchor="ctr"/>
           <a:lstStyle/>
           <a:p>
-            <a:pPr indent="0" marL="0">
+            <a:pPr marL="0" indent="0">
               <a:buNone/>
             </a:pPr>
             <a:r>
@@ -5726,6 +5580,7 @@
         <a:solidFill>
           <a:srgbClr val="1E2761"/>
         </a:solidFill>
+        <a:effectLst/>
       </p:bgPr>
     </p:bg>
     <p:spTree>
@@ -5763,7 +5618,7 @@
           <a:bodyPr wrap="square" lIns="0" tIns="0" rIns="0" bIns="0" rtlCol="0" anchor="ctr"/>
           <a:lstStyle/>
           <a:p>
-            <a:pPr indent="0" marL="0">
+            <a:pPr marL="0" indent="0">
               <a:buNone/>
             </a:pPr>
             <a:r>
@@ -5822,7 +5677,7 @@
           <a:bodyPr wrap="square" lIns="0" tIns="0" rIns="0" bIns="0" rtlCol="0" anchor="ctr"/>
           <a:lstStyle/>
           <a:p>
-            <a:pPr indent="0" marL="0">
+            <a:pPr marL="0" indent="0">
               <a:buNone/>
             </a:pPr>
             <a:r>
@@ -5861,7 +5716,7 @@
           <a:bodyPr wrap="square" lIns="0" tIns="0" rIns="0" bIns="0" rtlCol="0" anchor="ctr"/>
           <a:lstStyle/>
           <a:p>
-            <a:pPr indent="0" marL="0">
+            <a:pPr marL="0" indent="0">
               <a:buNone/>
             </a:pPr>
             <a:r>
@@ -5920,7 +5775,7 @@
           <a:bodyPr wrap="square" lIns="0" tIns="0" rIns="0" bIns="0" rtlCol="0" anchor="ctr"/>
           <a:lstStyle/>
           <a:p>
-            <a:pPr indent="0" marL="0">
+            <a:pPr marL="0" indent="0">
               <a:buNone/>
             </a:pPr>
             <a:r>
@@ -5959,7 +5814,7 @@
           <a:bodyPr wrap="square" lIns="0" tIns="0" rIns="0" bIns="0" rtlCol="0" anchor="ctr"/>
           <a:lstStyle/>
           <a:p>
-            <a:pPr indent="0" marL="0">
+            <a:pPr marL="0" indent="0">
               <a:buNone/>
             </a:pPr>
             <a:r>
@@ -6018,7 +5873,7 @@
           <a:bodyPr wrap="square" lIns="0" tIns="0" rIns="0" bIns="0" rtlCol="0" anchor="ctr"/>
           <a:lstStyle/>
           <a:p>
-            <a:pPr indent="0" marL="0">
+            <a:pPr marL="0" indent="0">
               <a:buNone/>
             </a:pPr>
             <a:r>
@@ -6057,7 +5912,7 @@
           <a:bodyPr wrap="square" lIns="0" tIns="0" rIns="0" bIns="0" rtlCol="0" anchor="ctr"/>
           <a:lstStyle/>
           <a:p>
-            <a:pPr indent="0" marL="0">
+            <a:pPr marL="0" indent="0">
               <a:buNone/>
             </a:pPr>
             <a:r>
@@ -6116,7 +5971,7 @@
           <a:bodyPr wrap="square" lIns="0" tIns="0" rIns="0" bIns="0" rtlCol="0" anchor="ctr"/>
           <a:lstStyle/>
           <a:p>
-            <a:pPr indent="0" marL="0">
+            <a:pPr marL="0" indent="0">
               <a:buNone/>
             </a:pPr>
             <a:r>
@@ -6155,7 +6010,7 @@
           <a:bodyPr wrap="square" lIns="0" tIns="0" rIns="0" bIns="0" rtlCol="0" anchor="ctr"/>
           <a:lstStyle/>
           <a:p>
-            <a:pPr indent="0" marL="0">
+            <a:pPr marL="0" indent="0">
               <a:buNone/>
             </a:pPr>
             <a:r>
@@ -6194,7 +6049,7 @@
           <a:bodyPr wrap="square" lIns="0" tIns="0" rIns="0" bIns="0" rtlCol="0" anchor="ctr"/>
           <a:lstStyle/>
           <a:p>
-            <a:pPr indent="0" marL="0">
+            <a:pPr marL="0" indent="0">
               <a:buNone/>
             </a:pPr>
             <a:r>
@@ -6233,7 +6088,7 @@
           <a:bodyPr wrap="square" lIns="0" tIns="0" rIns="0" bIns="0" rtlCol="0" anchor="ctr"/>
           <a:lstStyle/>
           <a:p>
-            <a:pPr indent="0" marL="0">
+            <a:pPr marL="0" indent="0">
               <a:buNone/>
             </a:pPr>
             <a:r>
@@ -6267,6 +6122,7 @@
         <a:solidFill>
           <a:srgbClr val="FFFFFF"/>
         </a:solidFill>
+        <a:effectLst/>
       </p:bgPr>
     </p:bg>
     <p:spTree>
@@ -6304,7 +6160,7 @@
           <a:bodyPr wrap="square" lIns="0" tIns="0" rIns="0" bIns="0" rtlCol="0" anchor="ctr"/>
           <a:lstStyle/>
           <a:p>
-            <a:pPr indent="0" marL="0">
+            <a:pPr marL="0" indent="0">
               <a:buNone/>
             </a:pPr>
             <a:r>
@@ -6343,7 +6199,7 @@
           <a:bodyPr wrap="square" lIns="0" tIns="0" rIns="0" bIns="0" rtlCol="0" anchor="ctr"/>
           <a:lstStyle/>
           <a:p>
-            <a:pPr indent="0" marL="0">
+            <a:pPr marL="0" indent="0">
               <a:buNone/>
             </a:pPr>
             <a:r>
@@ -6409,7 +6265,7 @@
           <a:bodyPr wrap="square" lIns="0" tIns="0" rIns="0" bIns="0" rtlCol="0" anchor="ctr"/>
           <a:lstStyle/>
           <a:p>
-            <a:pPr algn="ctr" indent="0" marL="0">
+            <a:pPr marL="0" indent="0" algn="ctr">
               <a:buNone/>
             </a:pPr>
             <a:r>
@@ -6448,7 +6304,7 @@
           <a:bodyPr wrap="square" lIns="0" tIns="0" rIns="0" bIns="0" rtlCol="0" anchor="ctr"/>
           <a:lstStyle/>
           <a:p>
-            <a:pPr algn="ctr" indent="0" marL="0">
+            <a:pPr marL="0" indent="0" algn="ctr">
               <a:buNone/>
             </a:pPr>
             <a:r>
@@ -6514,7 +6370,7 @@
           <a:bodyPr wrap="square" lIns="0" tIns="0" rIns="0" bIns="0" rtlCol="0" anchor="ctr"/>
           <a:lstStyle/>
           <a:p>
-            <a:pPr algn="ctr" indent="0" marL="0">
+            <a:pPr marL="0" indent="0" algn="ctr">
               <a:buNone/>
             </a:pPr>
             <a:r>
@@ -6553,7 +6409,7 @@
           <a:bodyPr wrap="square" lIns="0" tIns="0" rIns="0" bIns="0" rtlCol="0" anchor="ctr"/>
           <a:lstStyle/>
           <a:p>
-            <a:pPr algn="ctr" indent="0" marL="0">
+            <a:pPr marL="0" indent="0" algn="ctr">
               <a:buNone/>
             </a:pPr>
             <a:r>
@@ -6570,7 +6426,7 @@
             <a:endParaRPr lang="en-US" sz="1150" dirty="0"/>
           </a:p>
           <a:p>
-            <a:pPr algn="ctr" indent="0" marL="0">
+            <a:pPr marL="0" indent="0" algn="ctr">
               <a:buNone/>
             </a:pPr>
             <a:r>
@@ -6636,7 +6492,7 @@
           <a:bodyPr wrap="square" lIns="0" tIns="0" rIns="0" bIns="0" rtlCol="0" anchor="ctr"/>
           <a:lstStyle/>
           <a:p>
-            <a:pPr algn="ctr" indent="0" marL="0">
+            <a:pPr marL="0" indent="0" algn="ctr">
               <a:buNone/>
             </a:pPr>
             <a:r>
@@ -6675,7 +6531,7 @@
           <a:bodyPr wrap="square" lIns="0" tIns="0" rIns="0" bIns="0" rtlCol="0" anchor="ctr"/>
           <a:lstStyle/>
           <a:p>
-            <a:pPr algn="ctr" indent="0" marL="0">
+            <a:pPr marL="0" indent="0" algn="ctr">
               <a:buNone/>
             </a:pPr>
             <a:r>
@@ -6692,7 +6548,7 @@
             <a:endParaRPr lang="en-US" sz="1150" dirty="0"/>
           </a:p>
           <a:p>
-            <a:pPr algn="ctr" indent="0" marL="0">
+            <a:pPr marL="0" indent="0" algn="ctr">
               <a:buNone/>
             </a:pPr>
             <a:r>
@@ -6758,7 +6614,7 @@
           <a:bodyPr wrap="square" lIns="0" tIns="0" rIns="0" bIns="0" rtlCol="0" anchor="ctr"/>
           <a:lstStyle/>
           <a:p>
-            <a:pPr algn="ctr" indent="0" marL="0">
+            <a:pPr marL="0" indent="0" algn="ctr">
               <a:buNone/>
             </a:pPr>
             <a:r>
@@ -6797,7 +6653,7 @@
           <a:bodyPr wrap="square" lIns="0" tIns="0" rIns="0" bIns="0" rtlCol="0" anchor="ctr"/>
           <a:lstStyle/>
           <a:p>
-            <a:pPr algn="ctr" indent="0" marL="0">
+            <a:pPr marL="0" indent="0" algn="ctr">
               <a:buNone/>
             </a:pPr>
             <a:r>
@@ -6814,7 +6670,7 @@
             <a:endParaRPr lang="en-US" sz="1150" dirty="0"/>
           </a:p>
           <a:p>
-            <a:pPr algn="ctr" indent="0" marL="0">
+            <a:pPr marL="0" indent="0" algn="ctr">
               <a:buNone/>
             </a:pPr>
             <a:r>
@@ -6880,11 +6736,11 @@
           <a:bodyPr wrap="square" lIns="0" tIns="0" rIns="0" bIns="0" rtlCol="0" anchor="ctr"/>
           <a:lstStyle/>
           <a:p>
-            <a:pPr indent="0" marL="0">
+            <a:pPr marL="0" indent="0">
               <a:buNone/>
             </a:pPr>
             <a:r>
-              <a:rPr lang="en-US" sz="1150" b="1" spc="150" kern="0" dirty="0">
+              <a:rPr lang="en-US" sz="1150" b="1" kern="0" spc="150" dirty="0">
                 <a:solidFill>
                   <a:srgbClr val="1E9E6A"/>
                 </a:solidFill>
@@ -6919,7 +6775,7 @@
           <a:bodyPr wrap="square" lIns="0" tIns="0" rIns="0" bIns="0" rtlCol="0" anchor="ctr"/>
           <a:lstStyle/>
           <a:p>
-            <a:pPr indent="0" marL="0">
+            <a:pPr marL="0" indent="0">
               <a:lnSpc>
                 <a:spcPts val="1900"/>
               </a:lnSpc>
@@ -6961,7 +6817,7 @@
           <a:bodyPr wrap="square" lIns="0" tIns="0" rIns="0" bIns="0" rtlCol="0" anchor="ctr"/>
           <a:lstStyle/>
           <a:p>
-            <a:pPr indent="0" marL="0">
+            <a:pPr marL="0" indent="0">
               <a:lnSpc>
                 <a:spcPts val="1800"/>
               </a:lnSpc>
@@ -6998,6 +6854,7 @@
         <a:solidFill>
           <a:srgbClr val="FFFFFF"/>
         </a:solidFill>
+        <a:effectLst/>
       </p:bgPr>
     </p:bg>
     <p:spTree>
@@ -7035,7 +6892,7 @@
           <a:bodyPr wrap="square" lIns="0" tIns="0" rIns="0" bIns="0" rtlCol="0" anchor="ctr"/>
           <a:lstStyle/>
           <a:p>
-            <a:pPr indent="0" marL="0">
+            <a:pPr marL="0" indent="0">
               <a:buNone/>
             </a:pPr>
             <a:r>
@@ -7074,7 +6931,7 @@
           <a:bodyPr wrap="square" lIns="0" tIns="0" rIns="0" bIns="0" rtlCol="0" anchor="ctr"/>
           <a:lstStyle/>
           <a:p>
-            <a:pPr indent="0" marL="0">
+            <a:pPr marL="0" indent="0">
               <a:buNone/>
             </a:pPr>
             <a:r>
@@ -7133,7 +6990,7 @@
           <a:bodyPr wrap="square" lIns="0" tIns="0" rIns="0" bIns="0" rtlCol="0" anchor="ctr"/>
           <a:lstStyle/>
           <a:p>
-            <a:pPr algn="ctr" indent="0" marL="0">
+            <a:pPr marL="0" indent="0" algn="ctr">
               <a:buNone/>
             </a:pPr>
             <a:r>
@@ -7172,7 +7029,7 @@
           <a:bodyPr wrap="square" lIns="0" tIns="0" rIns="0" bIns="0" rtlCol="0" anchor="ctr"/>
           <a:lstStyle/>
           <a:p>
-            <a:pPr indent="0" marL="0">
+            <a:pPr marL="0" indent="0">
               <a:buNone/>
             </a:pPr>
             <a:r>
@@ -7211,7 +7068,7 @@
           <a:bodyPr wrap="square" lIns="0" tIns="0" rIns="0" bIns="0" rtlCol="0" anchor="ctr"/>
           <a:lstStyle/>
           <a:p>
-            <a:pPr indent="0" marL="0">
+            <a:pPr marL="0" indent="0">
               <a:lnSpc>
                 <a:spcPts val="1500"/>
               </a:lnSpc>
@@ -7273,7 +7130,7 @@
           <a:bodyPr wrap="square" lIns="0" tIns="0" rIns="0" bIns="0" rtlCol="0" anchor="ctr"/>
           <a:lstStyle/>
           <a:p>
-            <a:pPr algn="ctr" indent="0" marL="0">
+            <a:pPr marL="0" indent="0" algn="ctr">
               <a:buNone/>
             </a:pPr>
             <a:r>
@@ -7312,7 +7169,7 @@
           <a:bodyPr wrap="square" lIns="0" tIns="0" rIns="0" bIns="0" rtlCol="0" anchor="ctr"/>
           <a:lstStyle/>
           <a:p>
-            <a:pPr indent="0" marL="0">
+            <a:pPr marL="0" indent="0">
               <a:buNone/>
             </a:pPr>
             <a:r>
@@ -7351,7 +7208,7 @@
           <a:bodyPr wrap="square" lIns="0" tIns="0" rIns="0" bIns="0" rtlCol="0" anchor="ctr"/>
           <a:lstStyle/>
           <a:p>
-            <a:pPr indent="0" marL="0">
+            <a:pPr marL="0" indent="0">
               <a:lnSpc>
                 <a:spcPts val="1500"/>
               </a:lnSpc>
@@ -7413,7 +7270,7 @@
           <a:bodyPr wrap="square" lIns="0" tIns="0" rIns="0" bIns="0" rtlCol="0" anchor="ctr"/>
           <a:lstStyle/>
           <a:p>
-            <a:pPr algn="ctr" indent="0" marL="0">
+            <a:pPr marL="0" indent="0" algn="ctr">
               <a:buNone/>
             </a:pPr>
             <a:r>
@@ -7452,7 +7309,7 @@
           <a:bodyPr wrap="square" lIns="0" tIns="0" rIns="0" bIns="0" rtlCol="0" anchor="ctr"/>
           <a:lstStyle/>
           <a:p>
-            <a:pPr indent="0" marL="0">
+            <a:pPr marL="0" indent="0">
               <a:buNone/>
             </a:pPr>
             <a:r>
@@ -7491,7 +7348,7 @@
           <a:bodyPr wrap="square" lIns="0" tIns="0" rIns="0" bIns="0" rtlCol="0" anchor="ctr"/>
           <a:lstStyle/>
           <a:p>
-            <a:pPr indent="0" marL="0">
+            <a:pPr marL="0" indent="0">
               <a:lnSpc>
                 <a:spcPts val="1500"/>
               </a:lnSpc>
@@ -7553,7 +7410,7 @@
           <a:bodyPr wrap="square" lIns="0" tIns="0" rIns="0" bIns="0" rtlCol="0" anchor="ctr"/>
           <a:lstStyle/>
           <a:p>
-            <a:pPr algn="ctr" indent="0" marL="0">
+            <a:pPr marL="0" indent="0" algn="ctr">
               <a:buNone/>
             </a:pPr>
             <a:r>
@@ -7592,7 +7449,7 @@
           <a:bodyPr wrap="square" lIns="0" tIns="0" rIns="0" bIns="0" rtlCol="0" anchor="ctr"/>
           <a:lstStyle/>
           <a:p>
-            <a:pPr indent="0" marL="0">
+            <a:pPr marL="0" indent="0">
               <a:buNone/>
             </a:pPr>
             <a:r>
@@ -7631,7 +7488,7 @@
           <a:bodyPr wrap="square" lIns="0" tIns="0" rIns="0" bIns="0" rtlCol="0" anchor="ctr"/>
           <a:lstStyle/>
           <a:p>
-            <a:pPr indent="0" marL="0">
+            <a:pPr marL="0" indent="0">
               <a:lnSpc>
                 <a:spcPts val="1500"/>
               </a:lnSpc>
@@ -7668,6 +7525,7 @@
         <a:solidFill>
           <a:srgbClr val="FFFFFF"/>
         </a:solidFill>
+        <a:effectLst/>
       </p:bgPr>
     </p:bg>
     <p:spTree>
@@ -7705,7 +7563,7 @@
           <a:bodyPr wrap="square" lIns="0" tIns="0" rIns="0" bIns="0" rtlCol="0" anchor="ctr"/>
           <a:lstStyle/>
           <a:p>
-            <a:pPr indent="0" marL="0">
+            <a:pPr marL="0" indent="0">
               <a:buNone/>
             </a:pPr>
             <a:r>
@@ -7744,7 +7602,7 @@
           <a:bodyPr wrap="square" lIns="0" tIns="0" rIns="0" bIns="0" rtlCol="0" anchor="ctr"/>
           <a:lstStyle/>
           <a:p>
-            <a:pPr indent="0" marL="0">
+            <a:pPr marL="0" indent="0">
               <a:buNone/>
             </a:pPr>
             <a:r>
@@ -7778,17 +7636,41 @@
         </p:nvGraphicFramePr>
         <p:xfrm>
           <a:off x="640080" y="1481328"/>
-          <a:ext cx="10881360" cy="914400"/>
+          <a:ext cx="10881360" cy="3218688"/>
         </p:xfrm>
         <a:graphic>
           <a:graphicData uri="http://schemas.openxmlformats.org/drawingml/2006/table">
             <a:tbl>
               <a:tblPr/>
               <a:tblGrid>
-                <a:gridCol w="566928"/>
-                <a:gridCol w="3520440"/>
-                <a:gridCol w="5148072"/>
-                <a:gridCol w="1645920"/>
+                <a:gridCol w="566928">
+                  <a:extLst>
+                    <a:ext uri="{9D8B030D-6E8A-4147-A177-3AD203B41FA5}">
+                      <a16:colId xmlns:a16="http://schemas.microsoft.com/office/drawing/2014/main" val="20000"/>
+                    </a:ext>
+                  </a:extLst>
+                </a:gridCol>
+                <a:gridCol w="3520440">
+                  <a:extLst>
+                    <a:ext uri="{9D8B030D-6E8A-4147-A177-3AD203B41FA5}">
+                      <a16:colId xmlns:a16="http://schemas.microsoft.com/office/drawing/2014/main" val="20001"/>
+                    </a:ext>
+                  </a:extLst>
+                </a:gridCol>
+                <a:gridCol w="5148072">
+                  <a:extLst>
+                    <a:ext uri="{9D8B030D-6E8A-4147-A177-3AD203B41FA5}">
+                      <a16:colId xmlns:a16="http://schemas.microsoft.com/office/drawing/2014/main" val="20002"/>
+                    </a:ext>
+                  </a:extLst>
+                </a:gridCol>
+                <a:gridCol w="1645920">
+                  <a:extLst>
+                    <a:ext uri="{9D8B030D-6E8A-4147-A177-3AD203B41FA5}">
+                      <a16:colId xmlns:a16="http://schemas.microsoft.com/office/drawing/2014/main" val="20003"/>
+                    </a:ext>
+                  </a:extLst>
+                </a:gridCol>
               </a:tblGrid>
               <a:tr h="402336">
                 <a:tc>
@@ -7796,7 +7678,7 @@
                     <a:bodyPr/>
                     <a:lstStyle/>
                     <a:p>
-                      <a:pPr indent="0" marL="0">
+                      <a:pPr marL="0" indent="0">
                         <a:buNone/>
                       </a:pPr>
                       <a:r>
@@ -7817,7 +7699,7 @@
                       </a:endParaRPr>
                     </a:p>
                   </a:txBody>
-                  <a:tcPr marL="91440" marR="91440" marT="45720" marB="45720" anchor="ctr">
+                  <a:tcPr anchor="ctr">
                     <a:lnL w="12700" cap="flat" cmpd="sng" algn="ctr">
                       <a:solidFill>
                         <a:srgbClr val="E1E8F2"/>
@@ -7864,7 +7746,7 @@
                     <a:bodyPr/>
                     <a:lstStyle/>
                     <a:p>
-                      <a:pPr indent="0" marL="0">
+                      <a:pPr marL="0" indent="0">
                         <a:buNone/>
                       </a:pPr>
                       <a:r>
@@ -7885,7 +7767,7 @@
                       </a:endParaRPr>
                     </a:p>
                   </a:txBody>
-                  <a:tcPr marL="91440" marR="91440" marT="45720" marB="45720" anchor="ctr">
+                  <a:tcPr anchor="ctr">
                     <a:lnL w="12700" cap="flat" cmpd="sng" algn="ctr">
                       <a:solidFill>
                         <a:srgbClr val="E1E8F2"/>
@@ -7932,7 +7814,7 @@
                     <a:bodyPr/>
                     <a:lstStyle/>
                     <a:p>
-                      <a:pPr indent="0" marL="0">
+                      <a:pPr marL="0" indent="0">
                         <a:buNone/>
                       </a:pPr>
                       <a:r>
@@ -7953,7 +7835,7 @@
                       </a:endParaRPr>
                     </a:p>
                   </a:txBody>
-                  <a:tcPr marL="91440" marR="91440" marT="45720" marB="45720" anchor="ctr">
+                  <a:tcPr anchor="ctr">
                     <a:lnL w="12700" cap="flat" cmpd="sng" algn="ctr">
                       <a:solidFill>
                         <a:srgbClr val="E1E8F2"/>
@@ -8000,7 +7882,7 @@
                     <a:bodyPr/>
                     <a:lstStyle/>
                     <a:p>
-                      <a:pPr indent="0" marL="0">
+                      <a:pPr marL="0" indent="0">
                         <a:buNone/>
                       </a:pPr>
                       <a:r>
@@ -8021,7 +7903,7 @@
                       </a:endParaRPr>
                     </a:p>
                   </a:txBody>
-                  <a:tcPr marL="91440" marR="91440" marT="45720" marB="45720" anchor="ctr">
+                  <a:tcPr anchor="ctr">
                     <a:lnL w="12700" cap="flat" cmpd="sng" algn="ctr">
                       <a:solidFill>
                         <a:srgbClr val="E1E8F2"/>
@@ -8063,6 +7945,11 @@
                     </a:solidFill>
                   </a:tcPr>
                 </a:tc>
+                <a:extLst>
+                  <a:ext uri="{0D108BD9-81ED-4DB2-BD59-A6C34878D82A}">
+                    <a16:rowId xmlns:a16="http://schemas.microsoft.com/office/drawing/2014/main" val="10000"/>
+                  </a:ext>
+                </a:extLst>
               </a:tr>
               <a:tr h="402336">
                 <a:tc>
@@ -8070,7 +7957,7 @@
                     <a:bodyPr/>
                     <a:lstStyle/>
                     <a:p>
-                      <a:pPr indent="0" marL="0">
+                      <a:pPr marL="0" indent="0">
                         <a:buNone/>
                       </a:pPr>
                       <a:r>
@@ -8091,7 +7978,7 @@
                       </a:endParaRPr>
                     </a:p>
                   </a:txBody>
-                  <a:tcPr marL="91440" marR="91440" marT="45720" marB="45720" anchor="ctr">
+                  <a:tcPr anchor="ctr">
                     <a:lnL w="12700" cap="flat" cmpd="sng" algn="ctr">
                       <a:solidFill>
                         <a:srgbClr val="E1E8F2"/>
@@ -8135,7 +8022,7 @@
                     <a:bodyPr/>
                     <a:lstStyle/>
                     <a:p>
-                      <a:pPr indent="0" marL="0">
+                      <a:pPr marL="0" indent="0">
                         <a:buNone/>
                       </a:pPr>
                       <a:r>
@@ -8156,7 +8043,7 @@
                       </a:endParaRPr>
                     </a:p>
                   </a:txBody>
-                  <a:tcPr marL="91440" marR="91440" marT="45720" marB="45720" anchor="ctr">
+                  <a:tcPr anchor="ctr">
                     <a:lnL w="12700" cap="flat" cmpd="sng" algn="ctr">
                       <a:solidFill>
                         <a:srgbClr val="E1E8F2"/>
@@ -8200,7 +8087,7 @@
                     <a:bodyPr/>
                     <a:lstStyle/>
                     <a:p>
-                      <a:pPr indent="0" marL="0">
+                      <a:pPr marL="0" indent="0">
                         <a:buNone/>
                       </a:pPr>
                       <a:r>
@@ -8221,7 +8108,7 @@
                       </a:endParaRPr>
                     </a:p>
                   </a:txBody>
-                  <a:tcPr marL="91440" marR="91440" marT="45720" marB="45720" anchor="ctr">
+                  <a:tcPr anchor="ctr">
                     <a:lnL w="12700" cap="flat" cmpd="sng" algn="ctr">
                       <a:solidFill>
                         <a:srgbClr val="E1E8F2"/>
@@ -8265,7 +8152,7 @@
                     <a:bodyPr/>
                     <a:lstStyle/>
                     <a:p>
-                      <a:pPr indent="0" marL="0">
+                      <a:pPr marL="0" indent="0">
                         <a:buNone/>
                       </a:pPr>
                       <a:r>
@@ -8286,7 +8173,7 @@
                       </a:endParaRPr>
                     </a:p>
                   </a:txBody>
-                  <a:tcPr marL="91440" marR="91440" marT="45720" marB="45720" anchor="ctr">
+                  <a:tcPr anchor="ctr">
                     <a:lnL w="12700" cap="flat" cmpd="sng" algn="ctr">
                       <a:solidFill>
                         <a:srgbClr val="E1E8F2"/>
@@ -8325,6 +8212,11 @@
                     </a:lnB>
                   </a:tcPr>
                 </a:tc>
+                <a:extLst>
+                  <a:ext uri="{0D108BD9-81ED-4DB2-BD59-A6C34878D82A}">
+                    <a16:rowId xmlns:a16="http://schemas.microsoft.com/office/drawing/2014/main" val="10001"/>
+                  </a:ext>
+                </a:extLst>
               </a:tr>
               <a:tr h="402336">
                 <a:tc>
@@ -8332,7 +8224,7 @@
                     <a:bodyPr/>
                     <a:lstStyle/>
                     <a:p>
-                      <a:pPr indent="0" marL="0">
+                      <a:pPr marL="0" indent="0">
                         <a:buNone/>
                       </a:pPr>
                       <a:r>
@@ -8353,7 +8245,7 @@
                       </a:endParaRPr>
                     </a:p>
                   </a:txBody>
-                  <a:tcPr marL="91440" marR="91440" marT="45720" marB="45720" anchor="ctr">
+                  <a:tcPr anchor="ctr">
                     <a:lnL w="12700" cap="flat" cmpd="sng" algn="ctr">
                       <a:solidFill>
                         <a:srgbClr val="E1E8F2"/>
@@ -8397,7 +8289,7 @@
                     <a:bodyPr/>
                     <a:lstStyle/>
                     <a:p>
-                      <a:pPr indent="0" marL="0">
+                      <a:pPr marL="0" indent="0">
                         <a:buNone/>
                       </a:pPr>
                       <a:r>
@@ -8418,7 +8310,7 @@
                       </a:endParaRPr>
                     </a:p>
                   </a:txBody>
-                  <a:tcPr marL="91440" marR="91440" marT="45720" marB="45720" anchor="ctr">
+                  <a:tcPr anchor="ctr">
                     <a:lnL w="12700" cap="flat" cmpd="sng" algn="ctr">
                       <a:solidFill>
                         <a:srgbClr val="E1E8F2"/>
@@ -8462,7 +8354,7 @@
                     <a:bodyPr/>
                     <a:lstStyle/>
                     <a:p>
-                      <a:pPr indent="0" marL="0">
+                      <a:pPr marL="0" indent="0">
                         <a:buNone/>
                       </a:pPr>
                       <a:r>
@@ -8483,7 +8375,7 @@
                       </a:endParaRPr>
                     </a:p>
                   </a:txBody>
-                  <a:tcPr marL="91440" marR="91440" marT="45720" marB="45720" anchor="ctr">
+                  <a:tcPr anchor="ctr">
                     <a:lnL w="12700" cap="flat" cmpd="sng" algn="ctr">
                       <a:solidFill>
                         <a:srgbClr val="E1E8F2"/>
@@ -8527,7 +8419,7 @@
                     <a:bodyPr/>
                     <a:lstStyle/>
                     <a:p>
-                      <a:pPr indent="0" marL="0">
+                      <a:pPr marL="0" indent="0">
                         <a:buNone/>
                       </a:pPr>
                       <a:r>
@@ -8548,7 +8440,7 @@
                       </a:endParaRPr>
                     </a:p>
                   </a:txBody>
-                  <a:tcPr marL="91440" marR="91440" marT="45720" marB="45720" anchor="ctr">
+                  <a:tcPr anchor="ctr">
                     <a:lnL w="12700" cap="flat" cmpd="sng" algn="ctr">
                       <a:solidFill>
                         <a:srgbClr val="E1E8F2"/>
@@ -8587,6 +8479,11 @@
                     </a:lnB>
                   </a:tcPr>
                 </a:tc>
+                <a:extLst>
+                  <a:ext uri="{0D108BD9-81ED-4DB2-BD59-A6C34878D82A}">
+                    <a16:rowId xmlns:a16="http://schemas.microsoft.com/office/drawing/2014/main" val="10002"/>
+                  </a:ext>
+                </a:extLst>
               </a:tr>
               <a:tr h="402336">
                 <a:tc>
@@ -8594,7 +8491,7 @@
                     <a:bodyPr/>
                     <a:lstStyle/>
                     <a:p>
-                      <a:pPr indent="0" marL="0">
+                      <a:pPr marL="0" indent="0">
                         <a:buNone/>
                       </a:pPr>
                       <a:r>
@@ -8615,7 +8512,7 @@
                       </a:endParaRPr>
                     </a:p>
                   </a:txBody>
-                  <a:tcPr marL="91440" marR="91440" marT="45720" marB="45720" anchor="ctr">
+                  <a:tcPr anchor="ctr">
                     <a:lnL w="12700" cap="flat" cmpd="sng" algn="ctr">
                       <a:solidFill>
                         <a:srgbClr val="E1E8F2"/>
@@ -8659,7 +8556,7 @@
                     <a:bodyPr/>
                     <a:lstStyle/>
                     <a:p>
-                      <a:pPr indent="0" marL="0">
+                      <a:pPr marL="0" indent="0">
                         <a:buNone/>
                       </a:pPr>
                       <a:r>
@@ -8680,7 +8577,7 @@
                       </a:endParaRPr>
                     </a:p>
                   </a:txBody>
-                  <a:tcPr marL="91440" marR="91440" marT="45720" marB="45720" anchor="ctr">
+                  <a:tcPr anchor="ctr">
                     <a:lnL w="12700" cap="flat" cmpd="sng" algn="ctr">
                       <a:solidFill>
                         <a:srgbClr val="E1E8F2"/>
@@ -8724,7 +8621,7 @@
                     <a:bodyPr/>
                     <a:lstStyle/>
                     <a:p>
-                      <a:pPr indent="0" marL="0">
+                      <a:pPr marL="0" indent="0">
                         <a:buNone/>
                       </a:pPr>
                       <a:r>
@@ -8745,7 +8642,7 @@
                       </a:endParaRPr>
                     </a:p>
                   </a:txBody>
-                  <a:tcPr marL="91440" marR="91440" marT="45720" marB="45720" anchor="ctr">
+                  <a:tcPr anchor="ctr">
                     <a:lnL w="12700" cap="flat" cmpd="sng" algn="ctr">
                       <a:solidFill>
                         <a:srgbClr val="E1E8F2"/>
@@ -8789,7 +8686,7 @@
                     <a:bodyPr/>
                     <a:lstStyle/>
                     <a:p>
-                      <a:pPr indent="0" marL="0">
+                      <a:pPr marL="0" indent="0">
                         <a:buNone/>
                       </a:pPr>
                       <a:r>
@@ -8810,7 +8707,7 @@
                       </a:endParaRPr>
                     </a:p>
                   </a:txBody>
-                  <a:tcPr marL="91440" marR="91440" marT="45720" marB="45720" anchor="ctr">
+                  <a:tcPr anchor="ctr">
                     <a:lnL w="12700" cap="flat" cmpd="sng" algn="ctr">
                       <a:solidFill>
                         <a:srgbClr val="E1E8F2"/>
@@ -8849,6 +8746,11 @@
                     </a:lnB>
                   </a:tcPr>
                 </a:tc>
+                <a:extLst>
+                  <a:ext uri="{0D108BD9-81ED-4DB2-BD59-A6C34878D82A}">
+                    <a16:rowId xmlns:a16="http://schemas.microsoft.com/office/drawing/2014/main" val="10003"/>
+                  </a:ext>
+                </a:extLst>
               </a:tr>
               <a:tr h="402336">
                 <a:tc>
@@ -8856,7 +8758,7 @@
                     <a:bodyPr/>
                     <a:lstStyle/>
                     <a:p>
-                      <a:pPr indent="0" marL="0">
+                      <a:pPr marL="0" indent="0">
                         <a:buNone/>
                       </a:pPr>
                       <a:r>
@@ -8877,7 +8779,7 @@
                       </a:endParaRPr>
                     </a:p>
                   </a:txBody>
-                  <a:tcPr marL="91440" marR="91440" marT="45720" marB="45720" anchor="ctr">
+                  <a:tcPr anchor="ctr">
                     <a:lnL w="12700" cap="flat" cmpd="sng" algn="ctr">
                       <a:solidFill>
                         <a:srgbClr val="E1E8F2"/>
@@ -8921,7 +8823,7 @@
                     <a:bodyPr/>
                     <a:lstStyle/>
                     <a:p>
-                      <a:pPr indent="0" marL="0">
+                      <a:pPr marL="0" indent="0">
                         <a:buNone/>
                       </a:pPr>
                       <a:r>
@@ -8942,7 +8844,7 @@
                       </a:endParaRPr>
                     </a:p>
                   </a:txBody>
-                  <a:tcPr marL="91440" marR="91440" marT="45720" marB="45720" anchor="ctr">
+                  <a:tcPr anchor="ctr">
                     <a:lnL w="12700" cap="flat" cmpd="sng" algn="ctr">
                       <a:solidFill>
                         <a:srgbClr val="E1E8F2"/>
@@ -8986,7 +8888,7 @@
                     <a:bodyPr/>
                     <a:lstStyle/>
                     <a:p>
-                      <a:pPr indent="0" marL="0">
+                      <a:pPr marL="0" indent="0">
                         <a:buNone/>
                       </a:pPr>
                       <a:r>
@@ -9007,7 +8909,7 @@
                       </a:endParaRPr>
                     </a:p>
                   </a:txBody>
-                  <a:tcPr marL="91440" marR="91440" marT="45720" marB="45720" anchor="ctr">
+                  <a:tcPr anchor="ctr">
                     <a:lnL w="12700" cap="flat" cmpd="sng" algn="ctr">
                       <a:solidFill>
                         <a:srgbClr val="E1E8F2"/>
@@ -9051,7 +8953,7 @@
                     <a:bodyPr/>
                     <a:lstStyle/>
                     <a:p>
-                      <a:pPr indent="0" marL="0">
+                      <a:pPr marL="0" indent="0">
                         <a:buNone/>
                       </a:pPr>
                       <a:r>
@@ -9072,7 +8974,7 @@
                       </a:endParaRPr>
                     </a:p>
                   </a:txBody>
-                  <a:tcPr marL="91440" marR="91440" marT="45720" marB="45720" anchor="ctr">
+                  <a:tcPr anchor="ctr">
                     <a:lnL w="12700" cap="flat" cmpd="sng" algn="ctr">
                       <a:solidFill>
                         <a:srgbClr val="E1E8F2"/>
@@ -9111,6 +9013,11 @@
                     </a:lnB>
                   </a:tcPr>
                 </a:tc>
+                <a:extLst>
+                  <a:ext uri="{0D108BD9-81ED-4DB2-BD59-A6C34878D82A}">
+                    <a16:rowId xmlns:a16="http://schemas.microsoft.com/office/drawing/2014/main" val="10004"/>
+                  </a:ext>
+                </a:extLst>
               </a:tr>
               <a:tr h="402336">
                 <a:tc>
@@ -9118,7 +9025,7 @@
                     <a:bodyPr/>
                     <a:lstStyle/>
                     <a:p>
-                      <a:pPr indent="0" marL="0">
+                      <a:pPr marL="0" indent="0">
                         <a:buNone/>
                       </a:pPr>
                       <a:r>
@@ -9139,7 +9046,7 @@
                       </a:endParaRPr>
                     </a:p>
                   </a:txBody>
-                  <a:tcPr marL="91440" marR="91440" marT="45720" marB="45720" anchor="ctr">
+                  <a:tcPr anchor="ctr">
                     <a:lnL w="12700" cap="flat" cmpd="sng" algn="ctr">
                       <a:solidFill>
                         <a:srgbClr val="E1E8F2"/>
@@ -9183,7 +9090,7 @@
                     <a:bodyPr/>
                     <a:lstStyle/>
                     <a:p>
-                      <a:pPr indent="0" marL="0">
+                      <a:pPr marL="0" indent="0">
                         <a:buNone/>
                       </a:pPr>
                       <a:r>
@@ -9204,7 +9111,7 @@
                       </a:endParaRPr>
                     </a:p>
                   </a:txBody>
-                  <a:tcPr marL="91440" marR="91440" marT="45720" marB="45720" anchor="ctr">
+                  <a:tcPr anchor="ctr">
                     <a:lnL w="12700" cap="flat" cmpd="sng" algn="ctr">
                       <a:solidFill>
                         <a:srgbClr val="E1E8F2"/>
@@ -9248,7 +9155,7 @@
                     <a:bodyPr/>
                     <a:lstStyle/>
                     <a:p>
-                      <a:pPr indent="0" marL="0">
+                      <a:pPr marL="0" indent="0">
                         <a:buNone/>
                       </a:pPr>
                       <a:r>
@@ -9269,7 +9176,7 @@
                       </a:endParaRPr>
                     </a:p>
                   </a:txBody>
-                  <a:tcPr marL="91440" marR="91440" marT="45720" marB="45720" anchor="ctr">
+                  <a:tcPr anchor="ctr">
                     <a:lnL w="12700" cap="flat" cmpd="sng" algn="ctr">
                       <a:solidFill>
                         <a:srgbClr val="E1E8F2"/>
@@ -9313,7 +9220,7 @@
                     <a:bodyPr/>
                     <a:lstStyle/>
                     <a:p>
-                      <a:pPr indent="0" marL="0">
+                      <a:pPr marL="0" indent="0">
                         <a:buNone/>
                       </a:pPr>
                       <a:r>
@@ -9334,7 +9241,7 @@
                       </a:endParaRPr>
                     </a:p>
                   </a:txBody>
-                  <a:tcPr marL="91440" marR="91440" marT="45720" marB="45720" anchor="ctr">
+                  <a:tcPr anchor="ctr">
                     <a:lnL w="12700" cap="flat" cmpd="sng" algn="ctr">
                       <a:solidFill>
                         <a:srgbClr val="E1E8F2"/>
@@ -9373,6 +9280,11 @@
                     </a:lnB>
                   </a:tcPr>
                 </a:tc>
+                <a:extLst>
+                  <a:ext uri="{0D108BD9-81ED-4DB2-BD59-A6C34878D82A}">
+                    <a16:rowId xmlns:a16="http://schemas.microsoft.com/office/drawing/2014/main" val="10005"/>
+                  </a:ext>
+                </a:extLst>
               </a:tr>
               <a:tr h="402336">
                 <a:tc>
@@ -9380,7 +9292,7 @@
                     <a:bodyPr/>
                     <a:lstStyle/>
                     <a:p>
-                      <a:pPr indent="0" marL="0">
+                      <a:pPr marL="0" indent="0">
                         <a:buNone/>
                       </a:pPr>
                       <a:r>
@@ -9401,7 +9313,7 @@
                       </a:endParaRPr>
                     </a:p>
                   </a:txBody>
-                  <a:tcPr marL="91440" marR="91440" marT="45720" marB="45720" anchor="ctr">
+                  <a:tcPr anchor="ctr">
                     <a:lnL w="12700" cap="flat" cmpd="sng" algn="ctr">
                       <a:solidFill>
                         <a:srgbClr val="E1E8F2"/>
@@ -9445,7 +9357,7 @@
                     <a:bodyPr/>
                     <a:lstStyle/>
                     <a:p>
-                      <a:pPr indent="0" marL="0">
+                      <a:pPr marL="0" indent="0">
                         <a:buNone/>
                       </a:pPr>
                       <a:r>
@@ -9466,7 +9378,7 @@
                       </a:endParaRPr>
                     </a:p>
                   </a:txBody>
-                  <a:tcPr marL="91440" marR="91440" marT="45720" marB="45720" anchor="ctr">
+                  <a:tcPr anchor="ctr">
                     <a:lnL w="12700" cap="flat" cmpd="sng" algn="ctr">
                       <a:solidFill>
                         <a:srgbClr val="E1E8F2"/>
@@ -9510,7 +9422,7 @@
                     <a:bodyPr/>
                     <a:lstStyle/>
                     <a:p>
-                      <a:pPr indent="0" marL="0">
+                      <a:pPr marL="0" indent="0">
                         <a:buNone/>
                       </a:pPr>
                       <a:r>
@@ -9531,7 +9443,7 @@
                       </a:endParaRPr>
                     </a:p>
                   </a:txBody>
-                  <a:tcPr marL="91440" marR="91440" marT="45720" marB="45720" anchor="ctr">
+                  <a:tcPr anchor="ctr">
                     <a:lnL w="12700" cap="flat" cmpd="sng" algn="ctr">
                       <a:solidFill>
                         <a:srgbClr val="E1E8F2"/>
@@ -9575,7 +9487,7 @@
                     <a:bodyPr/>
                     <a:lstStyle/>
                     <a:p>
-                      <a:pPr indent="0" marL="0">
+                      <a:pPr marL="0" indent="0">
                         <a:buNone/>
                       </a:pPr>
                       <a:r>
@@ -9596,7 +9508,7 @@
                       </a:endParaRPr>
                     </a:p>
                   </a:txBody>
-                  <a:tcPr marL="91440" marR="91440" marT="45720" marB="45720" anchor="ctr">
+                  <a:tcPr anchor="ctr">
                     <a:lnL w="12700" cap="flat" cmpd="sng" algn="ctr">
                       <a:solidFill>
                         <a:srgbClr val="E1E8F2"/>
@@ -9635,6 +9547,11 @@
                     </a:lnB>
                   </a:tcPr>
                 </a:tc>
+                <a:extLst>
+                  <a:ext uri="{0D108BD9-81ED-4DB2-BD59-A6C34878D82A}">
+                    <a16:rowId xmlns:a16="http://schemas.microsoft.com/office/drawing/2014/main" val="10006"/>
+                  </a:ext>
+                </a:extLst>
               </a:tr>
               <a:tr h="402336">
                 <a:tc>
@@ -9642,7 +9559,7 @@
                     <a:bodyPr/>
                     <a:lstStyle/>
                     <a:p>
-                      <a:pPr indent="0" marL="0">
+                      <a:pPr marL="0" indent="0">
                         <a:buNone/>
                       </a:pPr>
                       <a:r>
@@ -9663,7 +9580,7 @@
                       </a:endParaRPr>
                     </a:p>
                   </a:txBody>
-                  <a:tcPr marL="91440" marR="91440" marT="45720" marB="45720" anchor="ctr">
+                  <a:tcPr anchor="ctr">
                     <a:lnL w="12700" cap="flat" cmpd="sng" algn="ctr">
                       <a:solidFill>
                         <a:srgbClr val="E1E8F2"/>
@@ -9707,7 +9624,7 @@
                     <a:bodyPr/>
                     <a:lstStyle/>
                     <a:p>
-                      <a:pPr indent="0" marL="0">
+                      <a:pPr marL="0" indent="0">
                         <a:buNone/>
                       </a:pPr>
                       <a:r>
@@ -9728,7 +9645,7 @@
                       </a:endParaRPr>
                     </a:p>
                   </a:txBody>
-                  <a:tcPr marL="91440" marR="91440" marT="45720" marB="45720" anchor="ctr">
+                  <a:tcPr anchor="ctr">
                     <a:lnL w="12700" cap="flat" cmpd="sng" algn="ctr">
                       <a:solidFill>
                         <a:srgbClr val="E1E8F2"/>
@@ -9772,7 +9689,7 @@
                     <a:bodyPr/>
                     <a:lstStyle/>
                     <a:p>
-                      <a:pPr indent="0" marL="0">
+                      <a:pPr marL="0" indent="0">
                         <a:buNone/>
                       </a:pPr>
                       <a:r>
@@ -9793,7 +9710,7 @@
                       </a:endParaRPr>
                     </a:p>
                   </a:txBody>
-                  <a:tcPr marL="91440" marR="91440" marT="45720" marB="45720" anchor="ctr">
+                  <a:tcPr anchor="ctr">
                     <a:lnL w="12700" cap="flat" cmpd="sng" algn="ctr">
                       <a:solidFill>
                         <a:srgbClr val="E1E8F2"/>
@@ -9837,7 +9754,7 @@
                     <a:bodyPr/>
                     <a:lstStyle/>
                     <a:p>
-                      <a:pPr indent="0" marL="0">
+                      <a:pPr marL="0" indent="0">
                         <a:buNone/>
                       </a:pPr>
                       <a:r>
@@ -9858,7 +9775,7 @@
                       </a:endParaRPr>
                     </a:p>
                   </a:txBody>
-                  <a:tcPr marL="91440" marR="91440" marT="45720" marB="45720" anchor="ctr">
+                  <a:tcPr anchor="ctr">
                     <a:lnL w="12700" cap="flat" cmpd="sng" algn="ctr">
                       <a:solidFill>
                         <a:srgbClr val="E1E8F2"/>
@@ -9897,6 +9814,11 @@
                     </a:lnB>
                   </a:tcPr>
                 </a:tc>
+                <a:extLst>
+                  <a:ext uri="{0D108BD9-81ED-4DB2-BD59-A6C34878D82A}">
+                    <a16:rowId xmlns:a16="http://schemas.microsoft.com/office/drawing/2014/main" val="10007"/>
+                  </a:ext>
+                </a:extLst>
               </a:tr>
             </a:tbl>
           </a:graphicData>
@@ -9918,6 +9840,7 @@
         <a:solidFill>
           <a:srgbClr val="FFFFFF"/>
         </a:solidFill>
+        <a:effectLst/>
       </p:bgPr>
     </p:bg>
     <p:spTree>
@@ -9955,7 +9878,7 @@
           <a:bodyPr wrap="square" lIns="0" tIns="0" rIns="0" bIns="0" rtlCol="0" anchor="ctr"/>
           <a:lstStyle/>
           <a:p>
-            <a:pPr indent="0" marL="0">
+            <a:pPr marL="0" indent="0">
               <a:buNone/>
             </a:pPr>
             <a:r>
@@ -9994,7 +9917,7 @@
           <a:bodyPr wrap="square" lIns="0" tIns="0" rIns="0" bIns="0" rtlCol="0" anchor="ctr"/>
           <a:lstStyle/>
           <a:p>
-            <a:pPr indent="0" marL="0">
+            <a:pPr marL="0" indent="0">
               <a:buNone/>
             </a:pPr>
             <a:r>
@@ -10028,18 +9951,48 @@
         </p:nvGraphicFramePr>
         <p:xfrm>
           <a:off x="640080" y="1481328"/>
-          <a:ext cx="10881360" cy="914400"/>
+          <a:ext cx="10881360" cy="2194560"/>
         </p:xfrm>
         <a:graphic>
           <a:graphicData uri="http://schemas.openxmlformats.org/drawingml/2006/table">
             <a:tbl>
               <a:tblPr/>
               <a:tblGrid>
-                <a:gridCol w="2103120"/>
-                <a:gridCol w="2377440"/>
-                <a:gridCol w="2377440"/>
-                <a:gridCol w="1737360"/>
-                <a:gridCol w="2286000"/>
+                <a:gridCol w="2103120">
+                  <a:extLst>
+                    <a:ext uri="{9D8B030D-6E8A-4147-A177-3AD203B41FA5}">
+                      <a16:colId xmlns:a16="http://schemas.microsoft.com/office/drawing/2014/main" val="20000"/>
+                    </a:ext>
+                  </a:extLst>
+                </a:gridCol>
+                <a:gridCol w="2377440">
+                  <a:extLst>
+                    <a:ext uri="{9D8B030D-6E8A-4147-A177-3AD203B41FA5}">
+                      <a16:colId xmlns:a16="http://schemas.microsoft.com/office/drawing/2014/main" val="20001"/>
+                    </a:ext>
+                  </a:extLst>
+                </a:gridCol>
+                <a:gridCol w="2377440">
+                  <a:extLst>
+                    <a:ext uri="{9D8B030D-6E8A-4147-A177-3AD203B41FA5}">
+                      <a16:colId xmlns:a16="http://schemas.microsoft.com/office/drawing/2014/main" val="20002"/>
+                    </a:ext>
+                  </a:extLst>
+                </a:gridCol>
+                <a:gridCol w="1737360">
+                  <a:extLst>
+                    <a:ext uri="{9D8B030D-6E8A-4147-A177-3AD203B41FA5}">
+                      <a16:colId xmlns:a16="http://schemas.microsoft.com/office/drawing/2014/main" val="20003"/>
+                    </a:ext>
+                  </a:extLst>
+                </a:gridCol>
+                <a:gridCol w="2286000">
+                  <a:extLst>
+                    <a:ext uri="{9D8B030D-6E8A-4147-A177-3AD203B41FA5}">
+                      <a16:colId xmlns:a16="http://schemas.microsoft.com/office/drawing/2014/main" val="20004"/>
+                    </a:ext>
+                  </a:extLst>
+                </a:gridCol>
               </a:tblGrid>
               <a:tr h="438912">
                 <a:tc>
@@ -10047,7 +10000,7 @@
                     <a:bodyPr/>
                     <a:lstStyle/>
                     <a:p>
-                      <a:pPr indent="0" marL="0">
+                      <a:pPr marL="0" indent="0">
                         <a:buNone/>
                       </a:pPr>
                       <a:r>
@@ -10068,7 +10021,7 @@
                       </a:endParaRPr>
                     </a:p>
                   </a:txBody>
-                  <a:tcPr marL="91440" marR="91440" marT="45720" marB="45720" anchor="ctr">
+                  <a:tcPr anchor="ctr">
                     <a:lnL w="12700" cap="flat" cmpd="sng" algn="ctr">
                       <a:solidFill>
                         <a:srgbClr val="E1E8F2"/>
@@ -10115,7 +10068,7 @@
                     <a:bodyPr/>
                     <a:lstStyle/>
                     <a:p>
-                      <a:pPr indent="0" marL="0">
+                      <a:pPr marL="0" indent="0">
                         <a:buNone/>
                       </a:pPr>
                       <a:r>
@@ -10136,7 +10089,7 @@
                       </a:endParaRPr>
                     </a:p>
                   </a:txBody>
-                  <a:tcPr marL="91440" marR="91440" marT="45720" marB="45720" anchor="ctr">
+                  <a:tcPr anchor="ctr">
                     <a:lnL w="12700" cap="flat" cmpd="sng" algn="ctr">
                       <a:solidFill>
                         <a:srgbClr val="E1E8F2"/>
@@ -10183,7 +10136,7 @@
                     <a:bodyPr/>
                     <a:lstStyle/>
                     <a:p>
-                      <a:pPr indent="0" marL="0">
+                      <a:pPr marL="0" indent="0">
                         <a:buNone/>
                       </a:pPr>
                       <a:r>
@@ -10204,7 +10157,7 @@
                       </a:endParaRPr>
                     </a:p>
                   </a:txBody>
-                  <a:tcPr marL="91440" marR="91440" marT="45720" marB="45720" anchor="ctr">
+                  <a:tcPr anchor="ctr">
                     <a:lnL w="12700" cap="flat" cmpd="sng" algn="ctr">
                       <a:solidFill>
                         <a:srgbClr val="E1E8F2"/>
@@ -10251,7 +10204,7 @@
                     <a:bodyPr/>
                     <a:lstStyle/>
                     <a:p>
-                      <a:pPr indent="0" marL="0">
+                      <a:pPr marL="0" indent="0">
                         <a:buNone/>
                       </a:pPr>
                       <a:r>
@@ -10272,7 +10225,7 @@
                       </a:endParaRPr>
                     </a:p>
                   </a:txBody>
-                  <a:tcPr marL="91440" marR="91440" marT="45720" marB="45720" anchor="ctr">
+                  <a:tcPr anchor="ctr">
                     <a:lnL w="12700" cap="flat" cmpd="sng" algn="ctr">
                       <a:solidFill>
                         <a:srgbClr val="E1E8F2"/>
@@ -10319,7 +10272,7 @@
                     <a:bodyPr/>
                     <a:lstStyle/>
                     <a:p>
-                      <a:pPr indent="0" marL="0">
+                      <a:pPr marL="0" indent="0">
                         <a:buNone/>
                       </a:pPr>
                       <a:r>
@@ -10340,7 +10293,7 @@
                       </a:endParaRPr>
                     </a:p>
                   </a:txBody>
-                  <a:tcPr marL="91440" marR="91440" marT="45720" marB="45720" anchor="ctr">
+                  <a:tcPr anchor="ctr">
                     <a:lnL w="12700" cap="flat" cmpd="sng" algn="ctr">
                       <a:solidFill>
                         <a:srgbClr val="E1E8F2"/>
@@ -10382,6 +10335,11 @@
                     </a:solidFill>
                   </a:tcPr>
                 </a:tc>
+                <a:extLst>
+                  <a:ext uri="{0D108BD9-81ED-4DB2-BD59-A6C34878D82A}">
+                    <a16:rowId xmlns:a16="http://schemas.microsoft.com/office/drawing/2014/main" val="10000"/>
+                  </a:ext>
+                </a:extLst>
               </a:tr>
               <a:tr h="438912">
                 <a:tc>
@@ -10389,7 +10347,7 @@
                     <a:bodyPr/>
                     <a:lstStyle/>
                     <a:p>
-                      <a:pPr indent="0" marL="0">
+                      <a:pPr marL="0" indent="0">
                         <a:buNone/>
                       </a:pPr>
                       <a:r>
@@ -10410,7 +10368,7 @@
                       </a:endParaRPr>
                     </a:p>
                   </a:txBody>
-                  <a:tcPr marL="91440" marR="91440" marT="45720" marB="45720" anchor="ctr">
+                  <a:tcPr anchor="ctr">
                     <a:lnL w="12700" cap="flat" cmpd="sng" algn="ctr">
                       <a:solidFill>
                         <a:srgbClr val="E1E8F2"/>
@@ -10454,7 +10412,7 @@
                     <a:bodyPr/>
                     <a:lstStyle/>
                     <a:p>
-                      <a:pPr indent="0" marL="0">
+                      <a:pPr marL="0" indent="0">
                         <a:buNone/>
                       </a:pPr>
                       <a:r>
@@ -10475,7 +10433,7 @@
                       </a:endParaRPr>
                     </a:p>
                   </a:txBody>
-                  <a:tcPr marL="91440" marR="91440" marT="45720" marB="45720" anchor="ctr">
+                  <a:tcPr anchor="ctr">
                     <a:lnL w="12700" cap="flat" cmpd="sng" algn="ctr">
                       <a:solidFill>
                         <a:srgbClr val="E1E8F2"/>
@@ -10519,7 +10477,7 @@
                     <a:bodyPr/>
                     <a:lstStyle/>
                     <a:p>
-                      <a:pPr indent="0" marL="0">
+                      <a:pPr marL="0" indent="0">
                         <a:buNone/>
                       </a:pPr>
                       <a:r>
@@ -10540,7 +10498,7 @@
                       </a:endParaRPr>
                     </a:p>
                   </a:txBody>
-                  <a:tcPr marL="91440" marR="91440" marT="45720" marB="45720" anchor="ctr">
+                  <a:tcPr anchor="ctr">
                     <a:lnL w="12700" cap="flat" cmpd="sng" algn="ctr">
                       <a:solidFill>
                         <a:srgbClr val="E1E8F2"/>
@@ -10584,7 +10542,7 @@
                     <a:bodyPr/>
                     <a:lstStyle/>
                     <a:p>
-                      <a:pPr indent="0" marL="0">
+                      <a:pPr marL="0" indent="0">
                         <a:buNone/>
                       </a:pPr>
                       <a:r>
@@ -10605,7 +10563,7 @@
                       </a:endParaRPr>
                     </a:p>
                   </a:txBody>
-                  <a:tcPr marL="91440" marR="91440" marT="45720" marB="45720" anchor="ctr">
+                  <a:tcPr anchor="ctr">
                     <a:lnL w="12700" cap="flat" cmpd="sng" algn="ctr">
                       <a:solidFill>
                         <a:srgbClr val="E1E8F2"/>
@@ -10649,7 +10607,7 @@
                     <a:bodyPr/>
                     <a:lstStyle/>
                     <a:p>
-                      <a:pPr indent="0" marL="0">
+                      <a:pPr marL="0" indent="0">
                         <a:buNone/>
                       </a:pPr>
                       <a:r>
@@ -10670,7 +10628,7 @@
                       </a:endParaRPr>
                     </a:p>
                   </a:txBody>
-                  <a:tcPr marL="91440" marR="91440" marT="45720" marB="45720" anchor="ctr">
+                  <a:tcPr anchor="ctr">
                     <a:lnL w="12700" cap="flat" cmpd="sng" algn="ctr">
                       <a:solidFill>
                         <a:srgbClr val="E1E8F2"/>
@@ -10709,6 +10667,11 @@
                     </a:lnB>
                   </a:tcPr>
                 </a:tc>
+                <a:extLst>
+                  <a:ext uri="{0D108BD9-81ED-4DB2-BD59-A6C34878D82A}">
+                    <a16:rowId xmlns:a16="http://schemas.microsoft.com/office/drawing/2014/main" val="10001"/>
+                  </a:ext>
+                </a:extLst>
               </a:tr>
               <a:tr h="438912">
                 <a:tc>
@@ -10716,7 +10679,7 @@
                     <a:bodyPr/>
                     <a:lstStyle/>
                     <a:p>
-                      <a:pPr indent="0" marL="0">
+                      <a:pPr marL="0" indent="0">
                         <a:buNone/>
                       </a:pPr>
                       <a:r>
@@ -10737,7 +10700,7 @@
                       </a:endParaRPr>
                     </a:p>
                   </a:txBody>
-                  <a:tcPr marL="91440" marR="91440" marT="45720" marB="45720" anchor="ctr">
+                  <a:tcPr anchor="ctr">
                     <a:lnL w="12700" cap="flat" cmpd="sng" algn="ctr">
                       <a:solidFill>
                         <a:srgbClr val="E1E8F2"/>
@@ -10781,7 +10744,7 @@
                     <a:bodyPr/>
                     <a:lstStyle/>
                     <a:p>
-                      <a:pPr indent="0" marL="0">
+                      <a:pPr marL="0" indent="0">
                         <a:buNone/>
                       </a:pPr>
                       <a:r>
@@ -10802,7 +10765,7 @@
                       </a:endParaRPr>
                     </a:p>
                   </a:txBody>
-                  <a:tcPr marL="91440" marR="91440" marT="45720" marB="45720" anchor="ctr">
+                  <a:tcPr anchor="ctr">
                     <a:lnL w="12700" cap="flat" cmpd="sng" algn="ctr">
                       <a:solidFill>
                         <a:srgbClr val="E1E8F2"/>
@@ -10846,7 +10809,7 @@
                     <a:bodyPr/>
                     <a:lstStyle/>
                     <a:p>
-                      <a:pPr indent="0" marL="0">
+                      <a:pPr marL="0" indent="0">
                         <a:buNone/>
                       </a:pPr>
                       <a:r>
@@ -10867,7 +10830,7 @@
                       </a:endParaRPr>
                     </a:p>
                   </a:txBody>
-                  <a:tcPr marL="91440" marR="91440" marT="45720" marB="45720" anchor="ctr">
+                  <a:tcPr anchor="ctr">
                     <a:lnL w="12700" cap="flat" cmpd="sng" algn="ctr">
                       <a:solidFill>
                         <a:srgbClr val="E1E8F2"/>
@@ -10911,7 +10874,7 @@
                     <a:bodyPr/>
                     <a:lstStyle/>
                     <a:p>
-                      <a:pPr indent="0" marL="0">
+                      <a:pPr marL="0" indent="0">
                         <a:buNone/>
                       </a:pPr>
                       <a:r>
@@ -10932,7 +10895,7 @@
                       </a:endParaRPr>
                     </a:p>
                   </a:txBody>
-                  <a:tcPr marL="91440" marR="91440" marT="45720" marB="45720" anchor="ctr">
+                  <a:tcPr anchor="ctr">
                     <a:lnL w="12700" cap="flat" cmpd="sng" algn="ctr">
                       <a:solidFill>
                         <a:srgbClr val="E1E8F2"/>
@@ -10976,7 +10939,7 @@
                     <a:bodyPr/>
                     <a:lstStyle/>
                     <a:p>
-                      <a:pPr indent="0" marL="0">
+                      <a:pPr marL="0" indent="0">
                         <a:buNone/>
                       </a:pPr>
                       <a:r>
@@ -10997,7 +10960,7 @@
                       </a:endParaRPr>
                     </a:p>
                   </a:txBody>
-                  <a:tcPr marL="91440" marR="91440" marT="45720" marB="45720" anchor="ctr">
+                  <a:tcPr anchor="ctr">
                     <a:lnL w="12700" cap="flat" cmpd="sng" algn="ctr">
                       <a:solidFill>
                         <a:srgbClr val="E1E8F2"/>
@@ -11036,6 +10999,11 @@
                     </a:lnB>
                   </a:tcPr>
                 </a:tc>
+                <a:extLst>
+                  <a:ext uri="{0D108BD9-81ED-4DB2-BD59-A6C34878D82A}">
+                    <a16:rowId xmlns:a16="http://schemas.microsoft.com/office/drawing/2014/main" val="10002"/>
+                  </a:ext>
+                </a:extLst>
               </a:tr>
               <a:tr h="438912">
                 <a:tc>
@@ -11043,7 +11011,7 @@
                     <a:bodyPr/>
                     <a:lstStyle/>
                     <a:p>
-                      <a:pPr indent="0" marL="0">
+                      <a:pPr marL="0" indent="0">
                         <a:buNone/>
                       </a:pPr>
                       <a:r>
@@ -11064,7 +11032,7 @@
                       </a:endParaRPr>
                     </a:p>
                   </a:txBody>
-                  <a:tcPr marL="91440" marR="91440" marT="45720" marB="45720" anchor="ctr">
+                  <a:tcPr anchor="ctr">
                     <a:lnL w="12700" cap="flat" cmpd="sng" algn="ctr">
                       <a:solidFill>
                         <a:srgbClr val="E1E8F2"/>
@@ -11108,7 +11076,7 @@
                     <a:bodyPr/>
                     <a:lstStyle/>
                     <a:p>
-                      <a:pPr indent="0" marL="0">
+                      <a:pPr marL="0" indent="0">
                         <a:buNone/>
                       </a:pPr>
                       <a:r>
@@ -11129,7 +11097,7 @@
                       </a:endParaRPr>
                     </a:p>
                   </a:txBody>
-                  <a:tcPr marL="91440" marR="91440" marT="45720" marB="45720" anchor="ctr">
+                  <a:tcPr anchor="ctr">
                     <a:lnL w="12700" cap="flat" cmpd="sng" algn="ctr">
                       <a:solidFill>
                         <a:srgbClr val="E1E8F2"/>
@@ -11173,7 +11141,7 @@
                     <a:bodyPr/>
                     <a:lstStyle/>
                     <a:p>
-                      <a:pPr indent="0" marL="0">
+                      <a:pPr marL="0" indent="0">
                         <a:buNone/>
                       </a:pPr>
                       <a:r>
@@ -11194,7 +11162,7 @@
                       </a:endParaRPr>
                     </a:p>
                   </a:txBody>
-                  <a:tcPr marL="91440" marR="91440" marT="45720" marB="45720" anchor="ctr">
+                  <a:tcPr anchor="ctr">
                     <a:lnL w="12700" cap="flat" cmpd="sng" algn="ctr">
                       <a:solidFill>
                         <a:srgbClr val="E1E8F2"/>
@@ -11238,7 +11206,7 @@
                     <a:bodyPr/>
                     <a:lstStyle/>
                     <a:p>
-                      <a:pPr indent="0" marL="0">
+                      <a:pPr marL="0" indent="0">
                         <a:buNone/>
                       </a:pPr>
                       <a:r>
@@ -11259,7 +11227,7 @@
                       </a:endParaRPr>
                     </a:p>
                   </a:txBody>
-                  <a:tcPr marL="91440" marR="91440" marT="45720" marB="45720" anchor="ctr">
+                  <a:tcPr anchor="ctr">
                     <a:lnL w="12700" cap="flat" cmpd="sng" algn="ctr">
                       <a:solidFill>
                         <a:srgbClr val="E1E8F2"/>
@@ -11303,7 +11271,7 @@
                     <a:bodyPr/>
                     <a:lstStyle/>
                     <a:p>
-                      <a:pPr indent="0" marL="0">
+                      <a:pPr marL="0" indent="0">
                         <a:buNone/>
                       </a:pPr>
                       <a:r>
@@ -11324,7 +11292,7 @@
                       </a:endParaRPr>
                     </a:p>
                   </a:txBody>
-                  <a:tcPr marL="91440" marR="91440" marT="45720" marB="45720" anchor="ctr">
+                  <a:tcPr anchor="ctr">
                     <a:lnL w="12700" cap="flat" cmpd="sng" algn="ctr">
                       <a:solidFill>
                         <a:srgbClr val="E1E8F2"/>
@@ -11363,6 +11331,11 @@
                     </a:lnB>
                   </a:tcPr>
                 </a:tc>
+                <a:extLst>
+                  <a:ext uri="{0D108BD9-81ED-4DB2-BD59-A6C34878D82A}">
+                    <a16:rowId xmlns:a16="http://schemas.microsoft.com/office/drawing/2014/main" val="10003"/>
+                  </a:ext>
+                </a:extLst>
               </a:tr>
               <a:tr h="438912">
                 <a:tc>
@@ -11370,7 +11343,7 @@
                     <a:bodyPr/>
                     <a:lstStyle/>
                     <a:p>
-                      <a:pPr indent="0" marL="0">
+                      <a:pPr marL="0" indent="0">
                         <a:buNone/>
                       </a:pPr>
                       <a:r>
@@ -11391,7 +11364,7 @@
                       </a:endParaRPr>
                     </a:p>
                   </a:txBody>
-                  <a:tcPr marL="91440" marR="91440" marT="45720" marB="45720" anchor="ctr">
+                  <a:tcPr anchor="ctr">
                     <a:lnL w="12700" cap="flat" cmpd="sng" algn="ctr">
                       <a:solidFill>
                         <a:srgbClr val="E1E8F2"/>
@@ -11435,7 +11408,7 @@
                     <a:bodyPr/>
                     <a:lstStyle/>
                     <a:p>
-                      <a:pPr indent="0" marL="0">
+                      <a:pPr marL="0" indent="0">
                         <a:buNone/>
                       </a:pPr>
                       <a:r>
@@ -11456,7 +11429,7 @@
                       </a:endParaRPr>
                     </a:p>
                   </a:txBody>
-                  <a:tcPr marL="91440" marR="91440" marT="45720" marB="45720" anchor="ctr">
+                  <a:tcPr anchor="ctr">
                     <a:lnL w="12700" cap="flat" cmpd="sng" algn="ctr">
                       <a:solidFill>
                         <a:srgbClr val="E1E8F2"/>
@@ -11500,7 +11473,7 @@
                     <a:bodyPr/>
                     <a:lstStyle/>
                     <a:p>
-                      <a:pPr indent="0" marL="0">
+                      <a:pPr marL="0" indent="0">
                         <a:buNone/>
                       </a:pPr>
                       <a:r>
@@ -11521,7 +11494,7 @@
                       </a:endParaRPr>
                     </a:p>
                   </a:txBody>
-                  <a:tcPr marL="91440" marR="91440" marT="45720" marB="45720" anchor="ctr">
+                  <a:tcPr anchor="ctr">
                     <a:lnL w="12700" cap="flat" cmpd="sng" algn="ctr">
                       <a:solidFill>
                         <a:srgbClr val="E1E8F2"/>
@@ -11565,7 +11538,7 @@
                     <a:bodyPr/>
                     <a:lstStyle/>
                     <a:p>
-                      <a:pPr indent="0" marL="0">
+                      <a:pPr marL="0" indent="0">
                         <a:buNone/>
                       </a:pPr>
                       <a:r>
@@ -11586,7 +11559,7 @@
                       </a:endParaRPr>
                     </a:p>
                   </a:txBody>
-                  <a:tcPr marL="91440" marR="91440" marT="45720" marB="45720" anchor="ctr">
+                  <a:tcPr anchor="ctr">
                     <a:lnL w="12700" cap="flat" cmpd="sng" algn="ctr">
                       <a:solidFill>
                         <a:srgbClr val="E1E8F2"/>
@@ -11630,7 +11603,7 @@
                     <a:bodyPr/>
                     <a:lstStyle/>
                     <a:p>
-                      <a:pPr indent="0" marL="0">
+                      <a:pPr marL="0" indent="0">
                         <a:buNone/>
                       </a:pPr>
                       <a:r>
@@ -11651,7 +11624,7 @@
                       </a:endParaRPr>
                     </a:p>
                   </a:txBody>
-                  <a:tcPr marL="91440" marR="91440" marT="45720" marB="45720" anchor="ctr">
+                  <a:tcPr anchor="ctr">
                     <a:lnL w="12700" cap="flat" cmpd="sng" algn="ctr">
                       <a:solidFill>
                         <a:srgbClr val="E1E8F2"/>
@@ -11690,6 +11663,11 @@
                     </a:lnB>
                   </a:tcPr>
                 </a:tc>
+                <a:extLst>
+                  <a:ext uri="{0D108BD9-81ED-4DB2-BD59-A6C34878D82A}">
+                    <a16:rowId xmlns:a16="http://schemas.microsoft.com/office/drawing/2014/main" val="10004"/>
+                  </a:ext>
+                </a:extLst>
               </a:tr>
             </a:tbl>
           </a:graphicData>
@@ -11724,7 +11702,7 @@
       </p:sp>
       <p:sp>
         <p:nvSpPr>
-          <p:cNvPr id="6" name="Text 3"/>
+          <p:cNvPr id="4" name="Text 3"/>
           <p:cNvSpPr/>
           <p:nvPr/>
         </p:nvSpPr>
@@ -11743,11 +11721,11 @@
           <a:bodyPr wrap="square" lIns="0" tIns="0" rIns="0" bIns="0" rtlCol="0" anchor="ctr"/>
           <a:lstStyle/>
           <a:p>
-            <a:pPr indent="0" marL="0">
+            <a:pPr marL="0" indent="0">
               <a:buNone/>
             </a:pPr>
             <a:r>
-              <a:rPr lang="en-US" sz="1100" b="1" spc="150" kern="0" dirty="0">
+              <a:rPr lang="en-US" sz="1100" b="1" kern="0" spc="150" dirty="0">
                 <a:solidFill>
                   <a:srgbClr val="1E9E6A"/>
                 </a:solidFill>
@@ -11782,7 +11760,7 @@
           <a:bodyPr wrap="square" lIns="0" tIns="0" rIns="0" bIns="0" rtlCol="0" anchor="ctr"/>
           <a:lstStyle/>
           <a:p>
-            <a:pPr indent="0" marL="0">
+            <a:pPr marL="0" indent="0">
               <a:lnSpc>
                 <a:spcPts val="1700"/>
               </a:lnSpc>
@@ -11851,11 +11829,11 @@
           <a:bodyPr wrap="square" lIns="0" tIns="0" rIns="0" bIns="0" rtlCol="0" anchor="ctr"/>
           <a:lstStyle/>
           <a:p>
-            <a:pPr indent="0" marL="0">
+            <a:pPr marL="0" indent="0">
               <a:buNone/>
             </a:pPr>
             <a:r>
-              <a:rPr lang="en-US" sz="1100" b="1" spc="150" kern="0" dirty="0">
+              <a:rPr lang="en-US" sz="1100" b="1" kern="0" spc="150" dirty="0">
                 <a:solidFill>
                   <a:srgbClr val="D98324"/>
                 </a:solidFill>
@@ -11890,7 +11868,7 @@
           <a:bodyPr wrap="square" lIns="0" tIns="0" rIns="0" bIns="0" rtlCol="0" anchor="ctr"/>
           <a:lstStyle/>
           <a:p>
-            <a:pPr indent="0" marL="0">
+            <a:pPr marL="0" indent="0">
               <a:lnSpc>
                 <a:spcPts val="1700"/>
               </a:lnSpc>
@@ -11927,6 +11905,7 @@
         <a:solidFill>
           <a:srgbClr val="FFFFFF"/>
         </a:solidFill>
+        <a:effectLst/>
       </p:bgPr>
     </p:bg>
     <p:spTree>
@@ -11964,7 +11943,7 @@
           <a:bodyPr wrap="square" lIns="0" tIns="0" rIns="0" bIns="0" rtlCol="0" anchor="ctr"/>
           <a:lstStyle/>
           <a:p>
-            <a:pPr indent="0" marL="0">
+            <a:pPr marL="0" indent="0">
               <a:buNone/>
             </a:pPr>
             <a:r>
@@ -12003,7 +11982,7 @@
           <a:bodyPr wrap="square" lIns="0" tIns="0" rIns="0" bIns="0" rtlCol="0" anchor="ctr"/>
           <a:lstStyle/>
           <a:p>
-            <a:pPr indent="0" marL="0">
+            <a:pPr marL="0" indent="0">
               <a:buNone/>
             </a:pPr>
             <a:r>
@@ -12023,7 +12002,7 @@
       </p:sp>
       <p:graphicFrame>
         <p:nvGraphicFramePr>
-          <p:cNvPr id="4" name="Chart 0" descr=""/>
+          <p:cNvPr id="4" name="Chart 0"/>
           <p:cNvGraphicFramePr/>
           <p:nvPr/>
         </p:nvGraphicFramePr>
@@ -12031,9 +12010,9 @@
           <a:off x="640080" y="1517904"/>
           <a:ext cx="7315200" cy="4480560"/>
         </p:xfrm>
-        <a:graphic xmlns:a="http://schemas.openxmlformats.org/drawingml/2006/main">
+        <a:graphic>
           <a:graphicData uri="http://schemas.openxmlformats.org/drawingml/2006/chart">
-            <c:chart xmlns:c="http://schemas.openxmlformats.org/drawingml/2006/chart" r:id="rId1"/>
+            <c:chart xmlns:c="http://schemas.openxmlformats.org/drawingml/2006/chart" xmlns:r="http://schemas.openxmlformats.org/officeDocument/2006/relationships" r:id="rId3"/>
           </a:graphicData>
         </a:graphic>
       </p:graphicFrame>
@@ -12085,11 +12064,11 @@
           <a:bodyPr wrap="square" lIns="0" tIns="0" rIns="0" bIns="0" rtlCol="0" anchor="ctr"/>
           <a:lstStyle/>
           <a:p>
-            <a:pPr indent="0" marL="0">
+            <a:pPr marL="0" indent="0">
               <a:buNone/>
             </a:pPr>
             <a:r>
-              <a:rPr lang="en-US" sz="1100" b="1" spc="120" kern="0" dirty="0">
+              <a:rPr lang="en-US" sz="1100" b="1" kern="0" spc="120" dirty="0">
                 <a:solidFill>
                   <a:srgbClr val="1E2761"/>
                 </a:solidFill>
@@ -12124,7 +12103,7 @@
           <a:bodyPr wrap="square" lIns="0" tIns="0" rIns="0" bIns="0" rtlCol="0" anchor="ctr"/>
           <a:lstStyle/>
           <a:p>
-            <a:pPr indent="0" marL="0">
+            <a:pPr marL="0" indent="0">
               <a:buNone/>
             </a:pPr>
             <a:r>
@@ -12163,7 +12142,7 @@
           <a:bodyPr wrap="square" lIns="0" tIns="0" rIns="0" bIns="0" rtlCol="0" anchor="ctr"/>
           <a:lstStyle/>
           <a:p>
-            <a:pPr indent="0" marL="0">
+            <a:pPr marL="0" indent="0">
               <a:lnSpc>
                 <a:spcPts val="1500"/>
               </a:lnSpc>
@@ -12232,11 +12211,11 @@
           <a:bodyPr wrap="square" lIns="0" tIns="0" rIns="0" bIns="0" rtlCol="0" anchor="ctr"/>
           <a:lstStyle/>
           <a:p>
-            <a:pPr indent="0" marL="0">
+            <a:pPr marL="0" indent="0">
               <a:buNone/>
             </a:pPr>
             <a:r>
-              <a:rPr lang="en-US" sz="1100" b="1" spc="120" kern="0" dirty="0">
+              <a:rPr lang="en-US" sz="1100" b="1" kern="0" spc="120" dirty="0">
                 <a:solidFill>
                   <a:srgbClr val="D98324"/>
                 </a:solidFill>
@@ -12271,7 +12250,7 @@
           <a:bodyPr wrap="square" lIns="0" tIns="0" rIns="0" bIns="0" rtlCol="0" anchor="ctr"/>
           <a:lstStyle/>
           <a:p>
-            <a:pPr indent="0" marL="0">
+            <a:pPr marL="0" indent="0">
               <a:lnSpc>
                 <a:spcPts val="1500"/>
               </a:lnSpc>
@@ -12308,6 +12287,7 @@
         <a:solidFill>
           <a:srgbClr val="FFFFFF"/>
         </a:solidFill>
+        <a:effectLst/>
       </p:bgPr>
     </p:bg>
     <p:spTree>
@@ -12345,7 +12325,7 @@
           <a:bodyPr wrap="square" lIns="0" tIns="0" rIns="0" bIns="0" rtlCol="0" anchor="ctr"/>
           <a:lstStyle/>
           <a:p>
-            <a:pPr indent="0" marL="0">
+            <a:pPr marL="0" indent="0">
               <a:buNone/>
             </a:pPr>
             <a:r>
@@ -12384,7 +12364,7 @@
           <a:bodyPr wrap="square" lIns="0" tIns="0" rIns="0" bIns="0" rtlCol="0" anchor="ctr"/>
           <a:lstStyle/>
           <a:p>
-            <a:pPr indent="0" marL="0">
+            <a:pPr marL="0" indent="0">
               <a:buNone/>
             </a:pPr>
             <a:r>
@@ -12443,7 +12423,7 @@
           <a:bodyPr wrap="square" lIns="0" tIns="0" rIns="0" bIns="0" rtlCol="0" anchor="ctr"/>
           <a:lstStyle/>
           <a:p>
-            <a:pPr algn="ctr" indent="0" marL="0">
+            <a:pPr marL="0" indent="0" algn="ctr">
               <a:buNone/>
             </a:pPr>
             <a:r>
@@ -12482,7 +12462,7 @@
           <a:bodyPr wrap="square" lIns="0" tIns="0" rIns="0" bIns="0" rtlCol="0" anchor="ctr"/>
           <a:lstStyle/>
           <a:p>
-            <a:pPr indent="0" marL="0">
+            <a:pPr marL="0" indent="0">
               <a:buNone/>
             </a:pPr>
             <a:r>
@@ -12521,7 +12501,7 @@
           <a:bodyPr wrap="square" lIns="0" tIns="0" rIns="0" bIns="0" rtlCol="0" anchor="ctr"/>
           <a:lstStyle/>
           <a:p>
-            <a:pPr indent="0" marL="0">
+            <a:pPr marL="0" indent="0">
               <a:lnSpc>
                 <a:spcPts val="1500"/>
               </a:lnSpc>
@@ -12583,7 +12563,7 @@
           <a:bodyPr wrap="square" lIns="0" tIns="0" rIns="0" bIns="0" rtlCol="0" anchor="ctr"/>
           <a:lstStyle/>
           <a:p>
-            <a:pPr algn="ctr" indent="0" marL="0">
+            <a:pPr marL="0" indent="0" algn="ctr">
               <a:buNone/>
             </a:pPr>
             <a:r>
@@ -12622,7 +12602,7 @@
           <a:bodyPr wrap="square" lIns="0" tIns="0" rIns="0" bIns="0" rtlCol="0" anchor="ctr"/>
           <a:lstStyle/>
           <a:p>
-            <a:pPr indent="0" marL="0">
+            <a:pPr marL="0" indent="0">
               <a:buNone/>
             </a:pPr>
             <a:r>
@@ -12661,7 +12641,7 @@
           <a:bodyPr wrap="square" lIns="0" tIns="0" rIns="0" bIns="0" rtlCol="0" anchor="ctr"/>
           <a:lstStyle/>
           <a:p>
-            <a:pPr indent="0" marL="0">
+            <a:pPr marL="0" indent="0">
               <a:lnSpc>
                 <a:spcPts val="1500"/>
               </a:lnSpc>
@@ -12723,7 +12703,7 @@
           <a:bodyPr wrap="square" lIns="0" tIns="0" rIns="0" bIns="0" rtlCol="0" anchor="ctr"/>
           <a:lstStyle/>
           <a:p>
-            <a:pPr algn="ctr" indent="0" marL="0">
+            <a:pPr marL="0" indent="0" algn="ctr">
               <a:buNone/>
             </a:pPr>
             <a:r>
@@ -12762,7 +12742,7 @@
           <a:bodyPr wrap="square" lIns="0" tIns="0" rIns="0" bIns="0" rtlCol="0" anchor="ctr"/>
           <a:lstStyle/>
           <a:p>
-            <a:pPr indent="0" marL="0">
+            <a:pPr marL="0" indent="0">
               <a:buNone/>
             </a:pPr>
             <a:r>
@@ -12801,7 +12781,7 @@
           <a:bodyPr wrap="square" lIns="0" tIns="0" rIns="0" bIns="0" rtlCol="0" anchor="ctr"/>
           <a:lstStyle/>
           <a:p>
-            <a:pPr indent="0" marL="0">
+            <a:pPr marL="0" indent="0">
               <a:lnSpc>
                 <a:spcPts val="1500"/>
               </a:lnSpc>
@@ -12863,7 +12843,7 @@
           <a:bodyPr wrap="square" lIns="0" tIns="0" rIns="0" bIns="0" rtlCol="0" anchor="ctr"/>
           <a:lstStyle/>
           <a:p>
-            <a:pPr algn="ctr" indent="0" marL="0">
+            <a:pPr marL="0" indent="0" algn="ctr">
               <a:buNone/>
             </a:pPr>
             <a:r>
@@ -12902,7 +12882,7 @@
           <a:bodyPr wrap="square" lIns="0" tIns="0" rIns="0" bIns="0" rtlCol="0" anchor="ctr"/>
           <a:lstStyle/>
           <a:p>
-            <a:pPr indent="0" marL="0">
+            <a:pPr marL="0" indent="0">
               <a:buNone/>
             </a:pPr>
             <a:r>
@@ -12941,7 +12921,7 @@
           <a:bodyPr wrap="square" lIns="0" tIns="0" rIns="0" bIns="0" rtlCol="0" anchor="ctr"/>
           <a:lstStyle/>
           <a:p>
-            <a:pPr indent="0" marL="0">
+            <a:pPr marL="0" indent="0">
               <a:lnSpc>
                 <a:spcPts val="1500"/>
               </a:lnSpc>
@@ -13003,7 +12983,7 @@
           <a:bodyPr wrap="square" lIns="0" tIns="0" rIns="0" bIns="0" rtlCol="0" anchor="ctr"/>
           <a:lstStyle/>
           <a:p>
-            <a:pPr algn="ctr" indent="0" marL="0">
+            <a:pPr marL="0" indent="0" algn="ctr">
               <a:buNone/>
             </a:pPr>
             <a:r>
@@ -13042,7 +13022,7 @@
           <a:bodyPr wrap="square" lIns="0" tIns="0" rIns="0" bIns="0" rtlCol="0" anchor="ctr"/>
           <a:lstStyle/>
           <a:p>
-            <a:pPr indent="0" marL="0">
+            <a:pPr marL="0" indent="0">
               <a:buNone/>
             </a:pPr>
             <a:r>
@@ -13081,7 +13061,7 @@
           <a:bodyPr wrap="square" lIns="0" tIns="0" rIns="0" bIns="0" rtlCol="0" anchor="ctr"/>
           <a:lstStyle/>
           <a:p>
-            <a:pPr indent="0" marL="0">
+            <a:pPr marL="0" indent="0">
               <a:lnSpc>
                 <a:spcPts val="1500"/>
               </a:lnSpc>
@@ -13143,7 +13123,7 @@
           <a:bodyPr wrap="square" lIns="0" tIns="0" rIns="0" bIns="0" rtlCol="0" anchor="ctr"/>
           <a:lstStyle/>
           <a:p>
-            <a:pPr algn="ctr" indent="0" marL="0">
+            <a:pPr marL="0" indent="0" algn="ctr">
               <a:buNone/>
             </a:pPr>
             <a:r>
@@ -13182,7 +13162,7 @@
           <a:bodyPr wrap="square" lIns="0" tIns="0" rIns="0" bIns="0" rtlCol="0" anchor="ctr"/>
           <a:lstStyle/>
           <a:p>
-            <a:pPr indent="0" marL="0">
+            <a:pPr marL="0" indent="0">
               <a:buNone/>
             </a:pPr>
             <a:r>
@@ -13221,7 +13201,7 @@
           <a:bodyPr wrap="square" lIns="0" tIns="0" rIns="0" bIns="0" rtlCol="0" anchor="ctr"/>
           <a:lstStyle/>
           <a:p>
-            <a:pPr indent="0" marL="0">
+            <a:pPr marL="0" indent="0">
               <a:lnSpc>
                 <a:spcPts val="1500"/>
               </a:lnSpc>
@@ -13258,6 +13238,7 @@
         <a:solidFill>
           <a:srgbClr val="FFFFFF"/>
         </a:solidFill>
+        <a:effectLst/>
       </p:bgPr>
     </p:bg>
     <p:spTree>
@@ -13295,7 +13276,7 @@
           <a:bodyPr wrap="square" lIns="0" tIns="0" rIns="0" bIns="0" rtlCol="0" anchor="ctr"/>
           <a:lstStyle/>
           <a:p>
-            <a:pPr indent="0" marL="0">
+            <a:pPr marL="0" indent="0">
               <a:buNone/>
             </a:pPr>
             <a:r>
@@ -13334,7 +13315,7 @@
           <a:bodyPr wrap="square" lIns="0" tIns="0" rIns="0" bIns="0" rtlCol="0" anchor="ctr"/>
           <a:lstStyle/>
           <a:p>
-            <a:pPr indent="0" marL="0">
+            <a:pPr marL="0" indent="0">
               <a:buNone/>
             </a:pPr>
             <a:r>
@@ -13368,17 +13349,41 @@
         </p:nvGraphicFramePr>
         <p:xfrm>
           <a:off x="640080" y="1536192"/>
-          <a:ext cx="10881360" cy="914400"/>
+          <a:ext cx="10881360" cy="3474720"/>
         </p:xfrm>
         <a:graphic>
           <a:graphicData uri="http://schemas.openxmlformats.org/drawingml/2006/table">
             <a:tbl>
               <a:tblPr/>
               <a:tblGrid>
-                <a:gridCol w="3200400"/>
-                <a:gridCol w="868680"/>
-                <a:gridCol w="5349240"/>
-                <a:gridCol w="1463040"/>
+                <a:gridCol w="3200400">
+                  <a:extLst>
+                    <a:ext uri="{9D8B030D-6E8A-4147-A177-3AD203B41FA5}">
+                      <a16:colId xmlns:a16="http://schemas.microsoft.com/office/drawing/2014/main" val="20000"/>
+                    </a:ext>
+                  </a:extLst>
+                </a:gridCol>
+                <a:gridCol w="868680">
+                  <a:extLst>
+                    <a:ext uri="{9D8B030D-6E8A-4147-A177-3AD203B41FA5}">
+                      <a16:colId xmlns:a16="http://schemas.microsoft.com/office/drawing/2014/main" val="20001"/>
+                    </a:ext>
+                  </a:extLst>
+                </a:gridCol>
+                <a:gridCol w="5349240">
+                  <a:extLst>
+                    <a:ext uri="{9D8B030D-6E8A-4147-A177-3AD203B41FA5}">
+                      <a16:colId xmlns:a16="http://schemas.microsoft.com/office/drawing/2014/main" val="20002"/>
+                    </a:ext>
+                  </a:extLst>
+                </a:gridCol>
+                <a:gridCol w="1463040">
+                  <a:extLst>
+                    <a:ext uri="{9D8B030D-6E8A-4147-A177-3AD203B41FA5}">
+                      <a16:colId xmlns:a16="http://schemas.microsoft.com/office/drawing/2014/main" val="20003"/>
+                    </a:ext>
+                  </a:extLst>
+                </a:gridCol>
               </a:tblGrid>
               <a:tr h="868680">
                 <a:tc>
@@ -13386,7 +13391,7 @@
                     <a:bodyPr/>
                     <a:lstStyle/>
                     <a:p>
-                      <a:pPr indent="0" marL="0">
+                      <a:pPr marL="0" indent="0">
                         <a:buNone/>
                       </a:pPr>
                       <a:r>
@@ -13407,7 +13412,7 @@
                       </a:endParaRPr>
                     </a:p>
                   </a:txBody>
-                  <a:tcPr marL="91440" marR="91440" marT="45720" marB="45720" anchor="ctr">
+                  <a:tcPr anchor="ctr">
                     <a:lnL w="12700" cap="flat" cmpd="sng" algn="ctr">
                       <a:solidFill>
                         <a:srgbClr val="E1E8F2"/>
@@ -13454,7 +13459,7 @@
                     <a:bodyPr/>
                     <a:lstStyle/>
                     <a:p>
-                      <a:pPr indent="0" marL="0">
+                      <a:pPr marL="0" indent="0">
                         <a:buNone/>
                       </a:pPr>
                       <a:r>
@@ -13475,7 +13480,7 @@
                       </a:endParaRPr>
                     </a:p>
                   </a:txBody>
-                  <a:tcPr marL="91440" marR="91440" marT="45720" marB="45720" anchor="ctr">
+                  <a:tcPr anchor="ctr">
                     <a:lnL w="12700" cap="flat" cmpd="sng" algn="ctr">
                       <a:solidFill>
                         <a:srgbClr val="E1E8F2"/>
@@ -13522,7 +13527,7 @@
                     <a:bodyPr/>
                     <a:lstStyle/>
                     <a:p>
-                      <a:pPr indent="0" marL="0">
+                      <a:pPr marL="0" indent="0">
                         <a:buNone/>
                       </a:pPr>
                       <a:r>
@@ -13543,7 +13548,7 @@
                       </a:endParaRPr>
                     </a:p>
                   </a:txBody>
-                  <a:tcPr marL="91440" marR="91440" marT="45720" marB="45720" anchor="ctr">
+                  <a:tcPr anchor="ctr">
                     <a:lnL w="12700" cap="flat" cmpd="sng" algn="ctr">
                       <a:solidFill>
                         <a:srgbClr val="E1E8F2"/>
@@ -13590,7 +13595,7 @@
                     <a:bodyPr/>
                     <a:lstStyle/>
                     <a:p>
-                      <a:pPr indent="0" marL="0">
+                      <a:pPr marL="0" indent="0">
                         <a:buNone/>
                       </a:pPr>
                       <a:r>
@@ -13611,7 +13616,7 @@
                       </a:endParaRPr>
                     </a:p>
                   </a:txBody>
-                  <a:tcPr marL="91440" marR="91440" marT="45720" marB="45720" anchor="ctr">
+                  <a:tcPr anchor="ctr">
                     <a:lnL w="12700" cap="flat" cmpd="sng" algn="ctr">
                       <a:solidFill>
                         <a:srgbClr val="E1E8F2"/>
@@ -13653,6 +13658,11 @@
                     </a:solidFill>
                   </a:tcPr>
                 </a:tc>
+                <a:extLst>
+                  <a:ext uri="{0D108BD9-81ED-4DB2-BD59-A6C34878D82A}">
+                    <a16:rowId xmlns:a16="http://schemas.microsoft.com/office/drawing/2014/main" val="10000"/>
+                  </a:ext>
+                </a:extLst>
               </a:tr>
               <a:tr h="868680">
                 <a:tc>
@@ -13660,7 +13670,7 @@
                     <a:bodyPr/>
                     <a:lstStyle/>
                     <a:p>
-                      <a:pPr indent="0" marL="0">
+                      <a:pPr marL="0" indent="0">
                         <a:buNone/>
                       </a:pPr>
                       <a:r>
@@ -13681,7 +13691,7 @@
                       </a:endParaRPr>
                     </a:p>
                   </a:txBody>
-                  <a:tcPr marL="91440" marR="91440" marT="45720" marB="45720" anchor="ctr">
+                  <a:tcPr anchor="ctr">
                     <a:lnL w="12700" cap="flat" cmpd="sng" algn="ctr">
                       <a:solidFill>
                         <a:srgbClr val="E1E8F2"/>
@@ -13725,7 +13735,7 @@
                     <a:bodyPr/>
                     <a:lstStyle/>
                     <a:p>
-                      <a:pPr indent="0" marL="0">
+                      <a:pPr marL="0" indent="0">
                         <a:buNone/>
                       </a:pPr>
                       <a:r>
@@ -13746,7 +13756,7 @@
                       </a:endParaRPr>
                     </a:p>
                   </a:txBody>
-                  <a:tcPr marL="91440" marR="91440" marT="45720" marB="45720" anchor="ctr">
+                  <a:tcPr anchor="ctr">
                     <a:lnL w="12700" cap="flat" cmpd="sng" algn="ctr">
                       <a:solidFill>
                         <a:srgbClr val="E1E8F2"/>
@@ -13790,7 +13800,7 @@
                     <a:bodyPr/>
                     <a:lstStyle/>
                     <a:p>
-                      <a:pPr indent="0" marL="0">
+                      <a:pPr marL="0" indent="0">
                         <a:buNone/>
                       </a:pPr>
                       <a:r>
@@ -13811,7 +13821,7 @@
                       </a:endParaRPr>
                     </a:p>
                   </a:txBody>
-                  <a:tcPr marL="91440" marR="91440" marT="45720" marB="45720" anchor="ctr">
+                  <a:tcPr anchor="ctr">
                     <a:lnL w="12700" cap="flat" cmpd="sng" algn="ctr">
                       <a:solidFill>
                         <a:srgbClr val="E1E8F2"/>
@@ -13855,7 +13865,7 @@
                     <a:bodyPr/>
                     <a:lstStyle/>
                     <a:p>
-                      <a:pPr indent="0" marL="0">
+                      <a:pPr marL="0" indent="0">
                         <a:buNone/>
                       </a:pPr>
                       <a:r>
@@ -13876,7 +13886,7 @@
                       </a:endParaRPr>
                     </a:p>
                   </a:txBody>
-                  <a:tcPr marL="91440" marR="91440" marT="45720" marB="45720" anchor="ctr">
+                  <a:tcPr anchor="ctr">
                     <a:lnL w="12700" cap="flat" cmpd="sng" algn="ctr">
                       <a:solidFill>
                         <a:srgbClr val="E1E8F2"/>
@@ -13915,6 +13925,11 @@
                     </a:lnB>
                   </a:tcPr>
                 </a:tc>
+                <a:extLst>
+                  <a:ext uri="{0D108BD9-81ED-4DB2-BD59-A6C34878D82A}">
+                    <a16:rowId xmlns:a16="http://schemas.microsoft.com/office/drawing/2014/main" val="10001"/>
+                  </a:ext>
+                </a:extLst>
               </a:tr>
               <a:tr h="868680">
                 <a:tc>
@@ -13922,7 +13937,7 @@
                     <a:bodyPr/>
                     <a:lstStyle/>
                     <a:p>
-                      <a:pPr indent="0" marL="0">
+                      <a:pPr marL="0" indent="0">
                         <a:buNone/>
                       </a:pPr>
                       <a:r>
@@ -13943,7 +13958,7 @@
                       </a:endParaRPr>
                     </a:p>
                   </a:txBody>
-                  <a:tcPr marL="91440" marR="91440" marT="45720" marB="45720" anchor="ctr">
+                  <a:tcPr anchor="ctr">
                     <a:lnL w="12700" cap="flat" cmpd="sng" algn="ctr">
                       <a:solidFill>
                         <a:srgbClr val="E1E8F2"/>
@@ -13987,7 +14002,7 @@
                     <a:bodyPr/>
                     <a:lstStyle/>
                     <a:p>
-                      <a:pPr indent="0" marL="0">
+                      <a:pPr marL="0" indent="0">
                         <a:buNone/>
                       </a:pPr>
                       <a:r>
@@ -14008,7 +14023,7 @@
                       </a:endParaRPr>
                     </a:p>
                   </a:txBody>
-                  <a:tcPr marL="91440" marR="91440" marT="45720" marB="45720" anchor="ctr">
+                  <a:tcPr anchor="ctr">
                     <a:lnL w="12700" cap="flat" cmpd="sng" algn="ctr">
                       <a:solidFill>
                         <a:srgbClr val="E1E8F2"/>
@@ -14052,7 +14067,7 @@
                     <a:bodyPr/>
                     <a:lstStyle/>
                     <a:p>
-                      <a:pPr indent="0" marL="0">
+                      <a:pPr marL="0" indent="0">
                         <a:buNone/>
                       </a:pPr>
                       <a:r>
@@ -14073,7 +14088,7 @@
                       </a:endParaRPr>
                     </a:p>
                   </a:txBody>
-                  <a:tcPr marL="91440" marR="91440" marT="45720" marB="45720" anchor="ctr">
+                  <a:tcPr anchor="ctr">
                     <a:lnL w="12700" cap="flat" cmpd="sng" algn="ctr">
                       <a:solidFill>
                         <a:srgbClr val="E1E8F2"/>
@@ -14117,7 +14132,7 @@
                     <a:bodyPr/>
                     <a:lstStyle/>
                     <a:p>
-                      <a:pPr indent="0" marL="0">
+                      <a:pPr marL="0" indent="0">
                         <a:buNone/>
                       </a:pPr>
                       <a:r>
@@ -14138,7 +14153,7 @@
                       </a:endParaRPr>
                     </a:p>
                   </a:txBody>
-                  <a:tcPr marL="91440" marR="91440" marT="45720" marB="45720" anchor="ctr">
+                  <a:tcPr anchor="ctr">
                     <a:lnL w="12700" cap="flat" cmpd="sng" algn="ctr">
                       <a:solidFill>
                         <a:srgbClr val="E1E8F2"/>
@@ -14177,6 +14192,11 @@
                     </a:lnB>
                   </a:tcPr>
                 </a:tc>
+                <a:extLst>
+                  <a:ext uri="{0D108BD9-81ED-4DB2-BD59-A6C34878D82A}">
+                    <a16:rowId xmlns:a16="http://schemas.microsoft.com/office/drawing/2014/main" val="10002"/>
+                  </a:ext>
+                </a:extLst>
               </a:tr>
               <a:tr h="868680">
                 <a:tc>
@@ -14184,7 +14204,7 @@
                     <a:bodyPr/>
                     <a:lstStyle/>
                     <a:p>
-                      <a:pPr indent="0" marL="0">
+                      <a:pPr marL="0" indent="0">
                         <a:buNone/>
                       </a:pPr>
                       <a:r>
@@ -14205,7 +14225,7 @@
                       </a:endParaRPr>
                     </a:p>
                   </a:txBody>
-                  <a:tcPr marL="91440" marR="91440" marT="45720" marB="45720" anchor="ctr">
+                  <a:tcPr anchor="ctr">
                     <a:lnL w="12700" cap="flat" cmpd="sng" algn="ctr">
                       <a:solidFill>
                         <a:srgbClr val="E1E8F2"/>
@@ -14249,7 +14269,7 @@
                     <a:bodyPr/>
                     <a:lstStyle/>
                     <a:p>
-                      <a:pPr indent="0" marL="0">
+                      <a:pPr marL="0" indent="0">
                         <a:buNone/>
                       </a:pPr>
                       <a:r>
@@ -14270,7 +14290,7 @@
                       </a:endParaRPr>
                     </a:p>
                   </a:txBody>
-                  <a:tcPr marL="91440" marR="91440" marT="45720" marB="45720" anchor="ctr">
+                  <a:tcPr anchor="ctr">
                     <a:lnL w="12700" cap="flat" cmpd="sng" algn="ctr">
                       <a:solidFill>
                         <a:srgbClr val="E1E8F2"/>
@@ -14314,7 +14334,7 @@
                     <a:bodyPr/>
                     <a:lstStyle/>
                     <a:p>
-                      <a:pPr indent="0" marL="0">
+                      <a:pPr marL="0" indent="0">
                         <a:buNone/>
                       </a:pPr>
                       <a:r>
@@ -14335,7 +14355,7 @@
                       </a:endParaRPr>
                     </a:p>
                   </a:txBody>
-                  <a:tcPr marL="91440" marR="91440" marT="45720" marB="45720" anchor="ctr">
+                  <a:tcPr anchor="ctr">
                     <a:lnL w="12700" cap="flat" cmpd="sng" algn="ctr">
                       <a:solidFill>
                         <a:srgbClr val="E1E8F2"/>
@@ -14379,7 +14399,7 @@
                     <a:bodyPr/>
                     <a:lstStyle/>
                     <a:p>
-                      <a:pPr indent="0" marL="0">
+                      <a:pPr marL="0" indent="0">
                         <a:buNone/>
                       </a:pPr>
                       <a:r>
@@ -14400,7 +14420,7 @@
                       </a:endParaRPr>
                     </a:p>
                   </a:txBody>
-                  <a:tcPr marL="91440" marR="91440" marT="45720" marB="45720" anchor="ctr">
+                  <a:tcPr anchor="ctr">
                     <a:lnL w="12700" cap="flat" cmpd="sng" algn="ctr">
                       <a:solidFill>
                         <a:srgbClr val="E1E8F2"/>
@@ -14439,6 +14459,11 @@
                     </a:lnB>
                   </a:tcPr>
                 </a:tc>
+                <a:extLst>
+                  <a:ext uri="{0D108BD9-81ED-4DB2-BD59-A6C34878D82A}">
+                    <a16:rowId xmlns:a16="http://schemas.microsoft.com/office/drawing/2014/main" val="10003"/>
+                  </a:ext>
+                </a:extLst>
               </a:tr>
             </a:tbl>
           </a:graphicData>
@@ -14452,7 +14477,7 @@
         </p:nvSpPr>
         <p:spPr>
           <a:xfrm>
-            <a:off x="640080" y="4645152"/>
+            <a:off x="579695" y="5126333"/>
             <a:ext cx="10881360" cy="1060704"/>
           </a:xfrm>
           <a:prstGeom prst="roundRect">
@@ -14479,7 +14504,7 @@
         </p:nvSpPr>
         <p:spPr>
           <a:xfrm>
-            <a:off x="914400" y="4864608"/>
+            <a:off x="854015" y="5321118"/>
             <a:ext cx="10332720" cy="566928"/>
           </a:xfrm>
           <a:prstGeom prst="rect">
@@ -14492,7 +14517,7 @@
           <a:bodyPr wrap="square" lIns="0" tIns="0" rIns="0" bIns="0" rtlCol="0" anchor="ctr"/>
           <a:lstStyle/>
           <a:p>
-            <a:pPr indent="0" marL="0">
+            <a:pPr marL="0" indent="0">
               <a:buNone/>
             </a:pPr>
             <a:r>
@@ -14526,6 +14551,7 @@
         <a:solidFill>
           <a:srgbClr val="FFFFFF"/>
         </a:solidFill>
+        <a:effectLst/>
       </p:bgPr>
     </p:bg>
     <p:spTree>
@@ -14563,7 +14589,7 @@
           <a:bodyPr wrap="square" lIns="0" tIns="0" rIns="0" bIns="0" rtlCol="0" anchor="ctr"/>
           <a:lstStyle/>
           <a:p>
-            <a:pPr indent="0" marL="0">
+            <a:pPr marL="0" indent="0">
               <a:buNone/>
             </a:pPr>
             <a:r>
@@ -14602,7 +14628,7 @@
           <a:bodyPr wrap="square" lIns="0" tIns="0" rIns="0" bIns="0" rtlCol="0" anchor="ctr"/>
           <a:lstStyle/>
           <a:p>
-            <a:pPr indent="0" marL="0">
+            <a:pPr marL="0" indent="0">
               <a:buNone/>
             </a:pPr>
             <a:r>
@@ -14668,11 +14694,11 @@
           <a:bodyPr wrap="square" lIns="0" tIns="0" rIns="0" bIns="0" rtlCol="0" anchor="ctr"/>
           <a:lstStyle/>
           <a:p>
-            <a:pPr indent="0" marL="0">
+            <a:pPr marL="0" indent="0">
               <a:buNone/>
             </a:pPr>
             <a:r>
-              <a:rPr lang="en-US" sz="1200" b="1" spc="150" kern="0" dirty="0">
+              <a:rPr lang="en-US" sz="1200" b="1" kern="0" spc="150" dirty="0">
                 <a:solidFill>
                   <a:srgbClr val="2D6CDF"/>
                 </a:solidFill>
@@ -14707,7 +14733,7 @@
           <a:bodyPr wrap="square" lIns="0" tIns="0" rIns="0" bIns="0" rtlCol="0" anchor="ctr"/>
           <a:lstStyle/>
           <a:p>
-            <a:pPr indent="0" marL="0">
+            <a:pPr marL="0" indent="0">
               <a:buNone/>
             </a:pPr>
             <a:r>
@@ -14746,7 +14772,7 @@
           <a:bodyPr wrap="square" lIns="0" tIns="0" rIns="0" bIns="0" rtlCol="0" anchor="ctr"/>
           <a:lstStyle/>
           <a:p>
-            <a:pPr indent="0" marL="0">
+            <a:pPr marL="0" indent="0">
               <a:buNone/>
             </a:pPr>
             <a:r>
@@ -14906,11 +14932,11 @@
           <a:bodyPr wrap="square" lIns="0" tIns="0" rIns="0" bIns="0" rtlCol="0" anchor="ctr"/>
           <a:lstStyle/>
           <a:p>
-            <a:pPr indent="0" marL="0">
+            <a:pPr marL="0" indent="0">
               <a:buNone/>
             </a:pPr>
             <a:r>
-              <a:rPr lang="en-US" sz="1200" b="1" spc="150" kern="0" dirty="0">
+              <a:rPr lang="en-US" sz="1200" b="1" kern="0" spc="150" dirty="0">
                 <a:solidFill>
                   <a:srgbClr val="2D6CDF"/>
                 </a:solidFill>
@@ -14945,7 +14971,7 @@
           <a:bodyPr wrap="square" lIns="0" tIns="0" rIns="0" bIns="0" rtlCol="0" anchor="ctr"/>
           <a:lstStyle/>
           <a:p>
-            <a:pPr indent="0" marL="0">
+            <a:pPr marL="0" indent="0">
               <a:buNone/>
             </a:pPr>
             <a:r>
@@ -14984,7 +15010,7 @@
           <a:bodyPr wrap="square" lIns="0" tIns="0" rIns="0" bIns="0" rtlCol="0" anchor="ctr"/>
           <a:lstStyle/>
           <a:p>
-            <a:pPr indent="0" marL="0">
+            <a:pPr marL="0" indent="0">
               <a:buNone/>
             </a:pPr>
             <a:r>
@@ -15397,4 +15423,319 @@
     </a:ext>
   </a:extLst>
 </a:theme>
+</file>
+
+<file path=ppt/theme/theme2.xml><?xml version="1.0" encoding="utf-8"?>
+<a:theme xmlns:a="http://schemas.openxmlformats.org/drawingml/2006/main" name="Office Theme">
+  <a:themeElements>
+    <a:clrScheme name="Office">
+      <a:dk1>
+        <a:sysClr val="windowText" lastClr="000000"/>
+      </a:dk1>
+      <a:lt1>
+        <a:sysClr val="window" lastClr="FFFFFF"/>
+      </a:lt1>
+      <a:dk2>
+        <a:srgbClr val="0E2841"/>
+      </a:dk2>
+      <a:lt2>
+        <a:srgbClr val="E8E8E8"/>
+      </a:lt2>
+      <a:accent1>
+        <a:srgbClr val="156082"/>
+      </a:accent1>
+      <a:accent2>
+        <a:srgbClr val="E97132"/>
+      </a:accent2>
+      <a:accent3>
+        <a:srgbClr val="196B24"/>
+      </a:accent3>
+      <a:accent4>
+        <a:srgbClr val="0F9ED5"/>
+      </a:accent4>
+      <a:accent5>
+        <a:srgbClr val="A02B93"/>
+      </a:accent5>
+      <a:accent6>
+        <a:srgbClr val="4EA72E"/>
+      </a:accent6>
+      <a:hlink>
+        <a:srgbClr val="467886"/>
+      </a:hlink>
+      <a:folHlink>
+        <a:srgbClr val="96607D"/>
+      </a:folHlink>
+    </a:clrScheme>
+    <a:fontScheme name="Office">
+      <a:majorFont>
+        <a:latin typeface="Aptos Display" panose="02110004020202020204"/>
+        <a:ea typeface=""/>
+        <a:cs typeface=""/>
+        <a:font script="Jpan" typeface="游ゴシック Light"/>
+        <a:font script="Hang" typeface="맑은 고딕"/>
+        <a:font script="Hans" typeface="等线 Light"/>
+        <a:font script="Hant" typeface="新細明體"/>
+        <a:font script="Arab" typeface="Times New Roman"/>
+        <a:font script="Hebr" typeface="Times New Roman"/>
+        <a:font script="Thai" typeface="Angsana New"/>
+        <a:font script="Ethi" typeface="Nyala"/>
+        <a:font script="Beng" typeface="Vrinda"/>
+        <a:font script="Gujr" typeface="Shruti"/>
+        <a:font script="Khmr" typeface="MoolBoran"/>
+        <a:font script="Knda" typeface="Tunga"/>
+        <a:font script="Guru" typeface="Raavi"/>
+        <a:font script="Cans" typeface="Euphemia"/>
+        <a:font script="Cher" typeface="Plantagenet Cherokee"/>
+        <a:font script="Yiii" typeface="Microsoft Yi Baiti"/>
+        <a:font script="Tibt" typeface="Microsoft Himalaya"/>
+        <a:font script="Thaa" typeface="MV Boli"/>
+        <a:font script="Deva" typeface="Mangal"/>
+        <a:font script="Telu" typeface="Gautami"/>
+        <a:font script="Taml" typeface="Latha"/>
+        <a:font script="Syrc" typeface="Estrangelo Edessa"/>
+        <a:font script="Orya" typeface="Kalinga"/>
+        <a:font script="Mlym" typeface="Kartika"/>
+        <a:font script="Laoo" typeface="DokChampa"/>
+        <a:font script="Sinh" typeface="Iskoola Pota"/>
+        <a:font script="Mong" typeface="Mongolian Baiti"/>
+        <a:font script="Viet" typeface="Times New Roman"/>
+        <a:font script="Uigh" typeface="Microsoft Uighur"/>
+        <a:font script="Geor" typeface="Sylfaen"/>
+        <a:font script="Armn" typeface="Arial"/>
+        <a:font script="Bugi" typeface="Leelawadee UI"/>
+        <a:font script="Bopo" typeface="Microsoft JhengHei"/>
+        <a:font script="Java" typeface="Javanese Text"/>
+        <a:font script="Lisu" typeface="Segoe UI"/>
+        <a:font script="Mymr" typeface="Myanmar Text"/>
+        <a:font script="Nkoo" typeface="Ebrima"/>
+        <a:font script="Olck" typeface="Nirmala UI"/>
+        <a:font script="Osma" typeface="Ebrima"/>
+        <a:font script="Phag" typeface="Phagspa"/>
+        <a:font script="Syrn" typeface="Estrangelo Edessa"/>
+        <a:font script="Syrj" typeface="Estrangelo Edessa"/>
+        <a:font script="Syre" typeface="Estrangelo Edessa"/>
+        <a:font script="Sora" typeface="Nirmala UI"/>
+        <a:font script="Tale" typeface="Microsoft Tai Le"/>
+        <a:font script="Talu" typeface="Microsoft New Tai Lue"/>
+        <a:font script="Tfng" typeface="Ebrima"/>
+      </a:majorFont>
+      <a:minorFont>
+        <a:latin typeface="Aptos" panose="02110004020202020204"/>
+        <a:ea typeface=""/>
+        <a:cs typeface=""/>
+        <a:font script="Jpan" typeface="游ゴシック"/>
+        <a:font script="Hang" typeface="맑은 고딕"/>
+        <a:font script="Hans" typeface="等线"/>
+        <a:font script="Hant" typeface="新細明體"/>
+        <a:font script="Arab" typeface="Arial"/>
+        <a:font script="Hebr" typeface="Arial"/>
+        <a:font script="Thai" typeface="Cordia New"/>
+        <a:font script="Ethi" typeface="Nyala"/>
+        <a:font script="Beng" typeface="Vrinda"/>
+        <a:font script="Gujr" typeface="Shruti"/>
+        <a:font script="Khmr" typeface="DaunPenh"/>
+        <a:font script="Knda" typeface="Tunga"/>
+        <a:font script="Guru" typeface="Raavi"/>
+        <a:font script="Cans" typeface="Euphemia"/>
+        <a:font script="Cher" typeface="Plantagenet Cherokee"/>
+        <a:font script="Yiii" typeface="Microsoft Yi Baiti"/>
+        <a:font script="Tibt" typeface="Microsoft Himalaya"/>
+        <a:font script="Thaa" typeface="MV Boli"/>
+        <a:font script="Deva" typeface="Mangal"/>
+        <a:font script="Telu" typeface="Gautami"/>
+        <a:font script="Taml" typeface="Latha"/>
+        <a:font script="Syrc" typeface="Estrangelo Edessa"/>
+        <a:font script="Orya" typeface="Kalinga"/>
+        <a:font script="Mlym" typeface="Kartika"/>
+        <a:font script="Laoo" typeface="DokChampa"/>
+        <a:font script="Sinh" typeface="Iskoola Pota"/>
+        <a:font script="Mong" typeface="Mongolian Baiti"/>
+        <a:font script="Viet" typeface="Arial"/>
+        <a:font script="Uigh" typeface="Microsoft Uighur"/>
+        <a:font script="Geor" typeface="Sylfaen"/>
+        <a:font script="Armn" typeface="Arial"/>
+        <a:font script="Bugi" typeface="Leelawadee UI"/>
+        <a:font script="Bopo" typeface="Microsoft JhengHei"/>
+        <a:font script="Java" typeface="Javanese Text"/>
+        <a:font script="Lisu" typeface="Segoe UI"/>
+        <a:font script="Mymr" typeface="Myanmar Text"/>
+        <a:font script="Nkoo" typeface="Ebrima"/>
+        <a:font script="Olck" typeface="Nirmala UI"/>
+        <a:font script="Osma" typeface="Ebrima"/>
+        <a:font script="Phag" typeface="Phagspa"/>
+        <a:font script="Syrn" typeface="Estrangelo Edessa"/>
+        <a:font script="Syrj" typeface="Estrangelo Edessa"/>
+        <a:font script="Syre" typeface="Estrangelo Edessa"/>
+        <a:font script="Sora" typeface="Nirmala UI"/>
+        <a:font script="Tale" typeface="Microsoft Tai Le"/>
+        <a:font script="Talu" typeface="Microsoft New Tai Lue"/>
+        <a:font script="Tfng" typeface="Ebrima"/>
+      </a:minorFont>
+    </a:fontScheme>
+    <a:fmtScheme name="Office">
+      <a:fillStyleLst>
+        <a:solidFill>
+          <a:schemeClr val="phClr"/>
+        </a:solidFill>
+        <a:gradFill rotWithShape="1">
+          <a:gsLst>
+            <a:gs pos="0">
+              <a:schemeClr val="phClr">
+                <a:lumMod val="110000"/>
+                <a:satMod val="105000"/>
+                <a:tint val="67000"/>
+              </a:schemeClr>
+            </a:gs>
+            <a:gs pos="50000">
+              <a:schemeClr val="phClr">
+                <a:lumMod val="105000"/>
+                <a:satMod val="103000"/>
+                <a:tint val="73000"/>
+              </a:schemeClr>
+            </a:gs>
+            <a:gs pos="100000">
+              <a:schemeClr val="phClr">
+                <a:lumMod val="105000"/>
+                <a:satMod val="109000"/>
+                <a:tint val="81000"/>
+              </a:schemeClr>
+            </a:gs>
+          </a:gsLst>
+          <a:lin ang="5400000" scaled="0"/>
+        </a:gradFill>
+        <a:gradFill rotWithShape="1">
+          <a:gsLst>
+            <a:gs pos="0">
+              <a:schemeClr val="phClr">
+                <a:satMod val="103000"/>
+                <a:lumMod val="102000"/>
+                <a:tint val="94000"/>
+              </a:schemeClr>
+            </a:gs>
+            <a:gs pos="50000">
+              <a:schemeClr val="phClr">
+                <a:satMod val="110000"/>
+                <a:lumMod val="100000"/>
+                <a:shade val="100000"/>
+              </a:schemeClr>
+            </a:gs>
+            <a:gs pos="100000">
+              <a:schemeClr val="phClr">
+                <a:lumMod val="99000"/>
+                <a:satMod val="120000"/>
+                <a:shade val="78000"/>
+              </a:schemeClr>
+            </a:gs>
+          </a:gsLst>
+          <a:lin ang="5400000" scaled="0"/>
+        </a:gradFill>
+      </a:fillStyleLst>
+      <a:lnStyleLst>
+        <a:ln w="12700" cap="flat" cmpd="sng" algn="ctr">
+          <a:solidFill>
+            <a:schemeClr val="phClr"/>
+          </a:solidFill>
+          <a:prstDash val="solid"/>
+          <a:miter lim="800000"/>
+        </a:ln>
+        <a:ln w="19050" cap="flat" cmpd="sng" algn="ctr">
+          <a:solidFill>
+            <a:schemeClr val="phClr"/>
+          </a:solidFill>
+          <a:prstDash val="solid"/>
+          <a:miter lim="800000"/>
+        </a:ln>
+        <a:ln w="25400" cap="flat" cmpd="sng" algn="ctr">
+          <a:solidFill>
+            <a:schemeClr val="phClr"/>
+          </a:solidFill>
+          <a:prstDash val="solid"/>
+          <a:miter lim="800000"/>
+        </a:ln>
+      </a:lnStyleLst>
+      <a:effectStyleLst>
+        <a:effectStyle>
+          <a:effectLst/>
+        </a:effectStyle>
+        <a:effectStyle>
+          <a:effectLst/>
+        </a:effectStyle>
+        <a:effectStyle>
+          <a:effectLst>
+            <a:outerShdw blurRad="57150" dist="19050" dir="5400000" algn="ctr" rotWithShape="0">
+              <a:srgbClr val="000000">
+                <a:alpha val="63000"/>
+              </a:srgbClr>
+            </a:outerShdw>
+          </a:effectLst>
+        </a:effectStyle>
+      </a:effectStyleLst>
+      <a:bgFillStyleLst>
+        <a:solidFill>
+          <a:schemeClr val="phClr"/>
+        </a:solidFill>
+        <a:solidFill>
+          <a:schemeClr val="phClr">
+            <a:tint val="95000"/>
+            <a:satMod val="170000"/>
+          </a:schemeClr>
+        </a:solidFill>
+        <a:gradFill rotWithShape="1">
+          <a:gsLst>
+            <a:gs pos="0">
+              <a:schemeClr val="phClr">
+                <a:tint val="93000"/>
+                <a:satMod val="150000"/>
+                <a:shade val="98000"/>
+                <a:lumMod val="102000"/>
+              </a:schemeClr>
+            </a:gs>
+            <a:gs pos="50000">
+              <a:schemeClr val="phClr">
+                <a:tint val="98000"/>
+                <a:satMod val="130000"/>
+                <a:shade val="90000"/>
+                <a:lumMod val="103000"/>
+              </a:schemeClr>
+            </a:gs>
+            <a:gs pos="100000">
+              <a:schemeClr val="phClr">
+                <a:shade val="63000"/>
+                <a:satMod val="120000"/>
+              </a:schemeClr>
+            </a:gs>
+          </a:gsLst>
+          <a:lin ang="5400000" scaled="0"/>
+        </a:gradFill>
+      </a:bgFillStyleLst>
+    </a:fmtScheme>
+  </a:themeElements>
+  <a:objectDefaults>
+    <a:lnDef>
+      <a:spPr/>
+      <a:bodyPr/>
+      <a:lstStyle/>
+      <a:style>
+        <a:lnRef idx="2">
+          <a:schemeClr val="accent1"/>
+        </a:lnRef>
+        <a:fillRef idx="0">
+          <a:schemeClr val="accent1"/>
+        </a:fillRef>
+        <a:effectRef idx="1">
+          <a:schemeClr val="accent1"/>
+        </a:effectRef>
+        <a:fontRef idx="minor">
+          <a:schemeClr val="tx1"/>
+        </a:fontRef>
+      </a:style>
+    </a:lnDef>
+  </a:objectDefaults>
+  <a:extraClrSchemeLst/>
+  <a:extLst>
+    <a:ext uri="{05A4C25C-085E-4340-85A3-A5531E510DB2}">
+      <thm15:themeFamily xmlns:thm15="http://schemas.microsoft.com/office/thememl/2012/main" name="Office Theme" id="{2E142A2C-CD16-42D6-873A-C26D2A0506FA}" vid="{1BDDFF52-6CD6-40A5-AB3C-68EB2F1E4D0A}"/>
+    </a:ext>
+  </a:extLst>
+</a:theme>
 </file>
</xml_diff>